<commit_message>
Reformula apresentação: remove foco em segurança, argumenta ROI de patch vs reescrita
Slide dedicado à senha exposta virou menção de passagem; novo slide
mostra que menos de 5% dos riscos mapeados se resolvem com ajustes
pontuais na planilha atual — o resto exige mudar a arquitetura.

Co-Authored-By: Claude Sonnet 5 <noreply@anthropic.com>
</commit_message>
<xml_diff>
--- a/docs/apresentacao/Quick_Data_Apresentacao.pptx
+++ b/docs/apresentacao/Quick_Data_Apresentacao.pptx
@@ -5150,7 +5150,7 @@
                 <a:ea typeface="Calibri" pitchFamily="34" charset="-122"/>
                 <a:cs typeface="Calibri" pitchFamily="34" charset="-120"/>
               </a:rPr>
-              <a:t>Mitigação imediata</a:t>
+              <a:t>Preparação</a:t>
             </a:r>
             <a:endParaRPr lang="en-US" sz="1400" dirty="0"/>
           </a:p>
@@ -5192,7 +5192,7 @@
                 <a:ea typeface="Calibri" pitchFamily="34" charset="-122"/>
                 <a:cs typeface="Calibri" pitchFamily="34" charset="-120"/>
               </a:rPr>
-              <a:t>Trocar a senha do banco. Confirmar com o time algumas regras que só vocês sabem responder.</a:t>
+              <a:t>Confirmar com o time algumas regras de negócio que só vocês sabem responder, antes de começar a reescrita de verdade.</a:t>
             </a:r>
             <a:endParaRPr lang="en-US" sz="1150" dirty="0"/>
           </a:p>
@@ -6008,7 +6008,7 @@
                 <a:ea typeface="Calibri" pitchFamily="34" charset="-122"/>
                 <a:cs typeface="Calibri" pitchFamily="34" charset="-120"/>
               </a:rPr>
-              <a:t>Aprovar a troca imediata da senha do banco de dados (custo baixo, já é risco hoje).</a:t>
+              <a:t>Aprovar seguir com a reescrita do Quick Data como aplicativo em Python — é o único caminho que resolve as causas, não só os sintomas.</a:t>
             </a:r>
             <a:endParaRPr lang="en-US" sz="1450" dirty="0"/>
           </a:p>
@@ -6109,7 +6109,7 @@
                 <a:ea typeface="Calibri" pitchFamily="34" charset="-122"/>
                 <a:cs typeface="Calibri" pitchFamily="34" charset="-120"/>
               </a:rPr>
-              <a:t>Aprovar seguir com a reescrita do Quick Data como aplicativo em Python.</a:t>
+              <a:t>Alocar tempo do time técnico sênior para conduzir a Fase 1 (motor de dados).</a:t>
             </a:r>
             <a:endParaRPr lang="en-US" sz="1450" dirty="0"/>
           </a:p>
@@ -6210,7 +6210,7 @@
                 <a:ea typeface="Calibri" pitchFamily="34" charset="-122"/>
                 <a:cs typeface="Calibri" pitchFamily="34" charset="-120"/>
               </a:rPr>
-              <a:t>Alocar tempo do time técnico sênior para conduzir a Fase 1 (motor de dados).</a:t>
+              <a:t>Uma rodada curta com os analistas para validar as poucas regras de negócio que só o time sabe responder.</a:t>
             </a:r>
             <a:endParaRPr lang="en-US" sz="1450" dirty="0"/>
           </a:p>
@@ -6218,108 +6218,7 @@
       </p:sp>
       <p:sp>
         <p:nvSpPr>
-          <p:cNvPr id="14" name="Shape 12"/>
-          <p:cNvSpPr/>
-          <p:nvPr/>
-        </p:nvSpPr>
-        <p:spPr>
-          <a:xfrm>
-            <a:off x="548640" y="4818888"/>
-            <a:ext cx="274320" cy="274320"/>
-          </a:xfrm>
-          <a:prstGeom prst="oval">
-            <a:avLst/>
-          </a:prstGeom>
-          <a:solidFill>
-            <a:srgbClr val="D10A11"/>
-          </a:solidFill>
-          <a:ln/>
-        </p:spPr>
-      </p:sp>
-      <p:sp>
-        <p:nvSpPr>
-          <p:cNvPr id="15" name="Text 13"/>
-          <p:cNvSpPr/>
-          <p:nvPr/>
-        </p:nvSpPr>
-        <p:spPr>
-          <a:xfrm>
-            <a:off x="548640" y="4818888"/>
-            <a:ext cx="274320" cy="274320"/>
-          </a:xfrm>
-          <a:prstGeom prst="rect">
-            <a:avLst/>
-          </a:prstGeom>
-          <a:noFill/>
-          <a:ln/>
-        </p:spPr>
-        <p:txBody>
-          <a:bodyPr wrap="square" lIns="0" tIns="0" rIns="0" bIns="0" rtlCol="0" anchor="ctr"/>
-          <a:lstStyle/>
-          <a:p>
-            <a:pPr algn="ctr" indent="0" marL="0">
-              <a:buNone/>
-            </a:pPr>
-            <a:r>
-              <a:rPr lang="en-US" sz="1200" b="1" dirty="0">
-                <a:solidFill>
-                  <a:srgbClr val="FFFFFF"/>
-                </a:solidFill>
-                <a:latin typeface="Calibri" pitchFamily="34" charset="0"/>
-                <a:ea typeface="Calibri" pitchFamily="34" charset="-122"/>
-                <a:cs typeface="Calibri" pitchFamily="34" charset="-120"/>
-              </a:rPr>
-              <a:t>4</a:t>
-            </a:r>
-            <a:endParaRPr lang="en-US" sz="1200" dirty="0"/>
-          </a:p>
-        </p:txBody>
-      </p:sp>
-      <p:sp>
-        <p:nvSpPr>
-          <p:cNvPr id="16" name="Text 14"/>
-          <p:cNvSpPr/>
-          <p:nvPr/>
-        </p:nvSpPr>
-        <p:spPr>
-          <a:xfrm>
-            <a:off x="1005840" y="4727448"/>
-            <a:ext cx="9601200" cy="640080"/>
-          </a:xfrm>
-          <a:prstGeom prst="rect">
-            <a:avLst/>
-          </a:prstGeom>
-          <a:noFill/>
-          <a:ln/>
-        </p:spPr>
-        <p:txBody>
-          <a:bodyPr wrap="square" lIns="0" tIns="0" rIns="0" bIns="0" rtlCol="0" anchor="ctr"/>
-          <a:lstStyle/>
-          <a:p>
-            <a:pPr indent="0" marL="0">
-              <a:lnSpc>
-                <a:spcPts val="1900"/>
-              </a:lnSpc>
-              <a:buNone/>
-            </a:pPr>
-            <a:r>
-              <a:rPr lang="en-US" sz="1450" dirty="0">
-                <a:solidFill>
-                  <a:srgbClr val="FFFFFF"/>
-                </a:solidFill>
-                <a:latin typeface="Calibri" pitchFamily="34" charset="0"/>
-                <a:ea typeface="Calibri" pitchFamily="34" charset="-122"/>
-                <a:cs typeface="Calibri" pitchFamily="34" charset="-120"/>
-              </a:rPr>
-              <a:t>Uma rodada curta com os analistas para validar as poucas regras de negócio que só o time sabe responder.</a:t>
-            </a:r>
-            <a:endParaRPr lang="en-US" sz="1450" dirty="0"/>
-          </a:p>
-        </p:txBody>
-      </p:sp>
-      <p:sp>
-        <p:nvSpPr>
-          <p:cNvPr id="17" name="Text 15"/>
+          <p:cNvPr id="14" name="Text 12"/>
           <p:cNvSpPr/>
           <p:nvPr/>
         </p:nvSpPr>
@@ -6358,7 +6257,7 @@
       </p:sp>
       <p:sp>
         <p:nvSpPr>
-          <p:cNvPr id="18" name="Text 16"/>
+          <p:cNvPr id="15" name="Text 13"/>
           <p:cNvSpPr/>
           <p:nvPr/>
         </p:nvSpPr>
@@ -6397,7 +6296,7 @@
       </p:sp>
       <p:sp>
         <p:nvSpPr>
-          <p:cNvPr id="19" name="Text 17"/>
+          <p:cNvPr id="16" name="Text 14"/>
           <p:cNvSpPr/>
           <p:nvPr/>
         </p:nvSpPr>
@@ -8651,7 +8550,7 @@
                 <a:ea typeface="Calibri" pitchFamily="34" charset="-122"/>
                 <a:cs typeface="Calibri" pitchFamily="34" charset="-120"/>
               </a:rPr>
-              <a:t>0</a:t>
+              <a:t>44 de 46</a:t>
             </a:r>
             <a:endParaRPr lang="en-US" sz="3000" dirty="0"/>
           </a:p>
@@ -8693,7 +8592,7 @@
                 <a:ea typeface="Calibri" pitchFamily="34" charset="-122"/>
                 <a:cs typeface="Calibri" pitchFamily="34" charset="-120"/>
               </a:rPr>
-              <a:t>riscos críticos são de “lentidão” — todos são de segurança ou confiabilidade do dado</a:t>
+              <a:t>só se resolvem mudando a arquitetura do sistema — não com ajustes pontuais na planilha atual</a:t>
             </a:r>
             <a:endParaRPr lang="en-US" sz="1300" dirty="0"/>
           </a:p>
@@ -8881,1271 +8780,405 @@
                 <a:ea typeface="Calibri" pitchFamily="34" charset="-122"/>
                 <a:cs typeface="Calibri" pitchFamily="34" charset="-120"/>
               </a:rPr>
-              <a:t>Por que remendar a planilha não resolve</a:t>
+              <a:t>Consertar por partes não compensa</a:t>
             </a:r>
             <a:endParaRPr lang="en-US" sz="3000" dirty="0"/>
           </a:p>
         </p:txBody>
       </p:sp>
-      <p:graphicFrame>
-        <p:nvGraphicFramePr>
-          <p:cNvPr id="7" name="Table 0"/>
-          <p:cNvGraphicFramePr>
-            <a:graphicFrameLocks noGrp="1"/>
-          </p:cNvGraphicFramePr>
-          <p:nvPr>
-            <p:extLst>
-              <p:ext uri="{D42A27DB-BD31-4B8C-83A1-F6EECF244321}">
-                <p14:modId xmlns:p14="http://schemas.microsoft.com/office/powerpoint/2010/main" val="1579011935"/>
-              </p:ext>
-            </p:extLst>
-          </p:nvPr>
-        </p:nvGraphicFramePr>
-        <p:xfrm>
-          <a:off x="548640" y="1691640"/>
-          <a:ext cx="11094415" cy="4206240"/>
-        </p:xfrm>
-        <a:graphic>
-          <a:graphicData uri="http://schemas.openxmlformats.org/drawingml/2006/table">
-            <a:tbl>
-              <a:tblPr/>
-              <a:tblGrid>
-                <a:gridCol w="6153912"/>
-                <a:gridCol w="2468880"/>
-                <a:gridCol w="2468880"/>
-              </a:tblGrid>
-              <a:tr h="667512">
-                <a:tc>
-                  <a:txBody>
-                    <a:bodyPr/>
-                    <a:lstStyle/>
-                    <a:p>
-                      <a:pPr algn="l" indent="0" marL="0">
-                        <a:buNone/>
-                      </a:pPr>
-                      <a:endParaRPr lang="en-US" sz="1300" dirty="0">
-                        <a:latin typeface="Calibri" charset="0"/>
-                        <a:ea typeface="Calibri" charset="0"/>
-                        <a:cs typeface="Calibri" charset="0"/>
-                      </a:endParaRPr>
-                    </a:p>
-                  </a:txBody>
-                  <a:tcPr marL="91440" marR="91440" marT="45720" marB="45720" anchor="ctr">
-                    <a:lnL w="9525" cap="flat" cmpd="sng" algn="ctr">
-                      <a:solidFill>
-                        <a:srgbClr val="E2E8F0"/>
-                      </a:solidFill>
-                      <a:prstDash val="solid"/>
-                      <a:round/>
-                      <a:headEnd type="none" w="med" len="med"/>
-                      <a:tailEnd type="none" w="med" len="med"/>
-                    </a:lnL>
-                    <a:lnR w="9525" cap="flat" cmpd="sng" algn="ctr">
-                      <a:solidFill>
-                        <a:srgbClr val="E2E8F0"/>
-                      </a:solidFill>
-                      <a:prstDash val="solid"/>
-                      <a:round/>
-                      <a:headEnd type="none" w="med" len="med"/>
-                      <a:tailEnd type="none" w="med" len="med"/>
-                    </a:lnR>
-                    <a:lnT w="9525" cap="flat" cmpd="sng" algn="ctr">
-                      <a:solidFill>
-                        <a:srgbClr val="E2E8F0"/>
-                      </a:solidFill>
-                      <a:prstDash val="solid"/>
-                      <a:round/>
-                      <a:headEnd type="none" w="med" len="med"/>
-                      <a:tailEnd type="none" w="med" len="med"/>
-                    </a:lnT>
-                    <a:lnB w="9525" cap="flat" cmpd="sng" algn="ctr">
-                      <a:solidFill>
-                        <a:srgbClr val="E2E8F0"/>
-                      </a:solidFill>
-                      <a:prstDash val="solid"/>
-                      <a:round/>
-                      <a:headEnd type="none" w="med" len="med"/>
-                      <a:tailEnd type="none" w="med" len="med"/>
-                    </a:lnB>
-                    <a:solidFill>
-                      <a:srgbClr val="004691"/>
-                    </a:solidFill>
-                  </a:tcPr>
-                </a:tc>
-                <a:tc>
-                  <a:txBody>
-                    <a:bodyPr/>
-                    <a:lstStyle/>
-                    <a:p>
-                      <a:pPr algn="ctr" indent="0" marL="0">
-                        <a:buNone/>
-                      </a:pPr>
-                      <a:r>
-                        <a:rPr lang="en-US" sz="1300" b="1" dirty="0">
-                          <a:solidFill>
-                            <a:srgbClr val="FFFFFF"/>
-                          </a:solidFill>
-                          <a:latin typeface="Calibri" pitchFamily="34" charset="0"/>
-                          <a:ea typeface="Calibri" pitchFamily="34" charset="-122"/>
-                          <a:cs typeface="Calibri" pitchFamily="34" charset="-120"/>
-                        </a:rPr>
-                        <a:t>Planilha atual</a:t>
-                      </a:r>
-                      <a:endParaRPr lang="en-US" sz="1300" dirty="0">
-                        <a:latin typeface="Calibri" charset="0"/>
-                        <a:ea typeface="Calibri" charset="0"/>
-                        <a:cs typeface="Calibri" charset="0"/>
-                      </a:endParaRPr>
-                    </a:p>
-                  </a:txBody>
-                  <a:tcPr marL="91440" marR="91440" marT="45720" marB="45720" anchor="ctr">
-                    <a:lnL w="9525" cap="flat" cmpd="sng" algn="ctr">
-                      <a:solidFill>
-                        <a:srgbClr val="E2E8F0"/>
-                      </a:solidFill>
-                      <a:prstDash val="solid"/>
-                      <a:round/>
-                      <a:headEnd type="none" w="med" len="med"/>
-                      <a:tailEnd type="none" w="med" len="med"/>
-                    </a:lnL>
-                    <a:lnR w="9525" cap="flat" cmpd="sng" algn="ctr">
-                      <a:solidFill>
-                        <a:srgbClr val="E2E8F0"/>
-                      </a:solidFill>
-                      <a:prstDash val="solid"/>
-                      <a:round/>
-                      <a:headEnd type="none" w="med" len="med"/>
-                      <a:tailEnd type="none" w="med" len="med"/>
-                    </a:lnR>
-                    <a:lnT w="9525" cap="flat" cmpd="sng" algn="ctr">
-                      <a:solidFill>
-                        <a:srgbClr val="E2E8F0"/>
-                      </a:solidFill>
-                      <a:prstDash val="solid"/>
-                      <a:round/>
-                      <a:headEnd type="none" w="med" len="med"/>
-                      <a:tailEnd type="none" w="med" len="med"/>
-                    </a:lnT>
-                    <a:lnB w="9525" cap="flat" cmpd="sng" algn="ctr">
-                      <a:solidFill>
-                        <a:srgbClr val="E2E8F0"/>
-                      </a:solidFill>
-                      <a:prstDash val="solid"/>
-                      <a:round/>
-                      <a:headEnd type="none" w="med" len="med"/>
-                      <a:tailEnd type="none" w="med" len="med"/>
-                    </a:lnB>
-                    <a:solidFill>
-                      <a:srgbClr val="004691"/>
-                    </a:solidFill>
-                  </a:tcPr>
-                </a:tc>
-                <a:tc>
-                  <a:txBody>
-                    <a:bodyPr/>
-                    <a:lstStyle/>
-                    <a:p>
-                      <a:pPr algn="ctr" indent="0" marL="0">
-                        <a:buNone/>
-                      </a:pPr>
-                      <a:r>
-                        <a:rPr lang="en-US" sz="1300" b="1" dirty="0">
-                          <a:solidFill>
-                            <a:srgbClr val="FFFFFF"/>
-                          </a:solidFill>
-                          <a:latin typeface="Calibri" pitchFamily="34" charset="0"/>
-                          <a:ea typeface="Calibri" pitchFamily="34" charset="-122"/>
-                          <a:cs typeface="Calibri" pitchFamily="34" charset="-120"/>
-                        </a:rPr>
-                        <a:t>Aplicativo novo</a:t>
-                      </a:r>
-                      <a:endParaRPr lang="en-US" sz="1300" dirty="0">
-                        <a:latin typeface="Calibri" charset="0"/>
-                        <a:ea typeface="Calibri" charset="0"/>
-                        <a:cs typeface="Calibri" charset="0"/>
-                      </a:endParaRPr>
-                    </a:p>
-                  </a:txBody>
-                  <a:tcPr marL="91440" marR="91440" marT="45720" marB="45720" anchor="ctr">
-                    <a:lnL w="9525" cap="flat" cmpd="sng" algn="ctr">
-                      <a:solidFill>
-                        <a:srgbClr val="E2E8F0"/>
-                      </a:solidFill>
-                      <a:prstDash val="solid"/>
-                      <a:round/>
-                      <a:headEnd type="none" w="med" len="med"/>
-                      <a:tailEnd type="none" w="med" len="med"/>
-                    </a:lnL>
-                    <a:lnR w="9525" cap="flat" cmpd="sng" algn="ctr">
-                      <a:solidFill>
-                        <a:srgbClr val="E2E8F0"/>
-                      </a:solidFill>
-                      <a:prstDash val="solid"/>
-                      <a:round/>
-                      <a:headEnd type="none" w="med" len="med"/>
-                      <a:tailEnd type="none" w="med" len="med"/>
-                    </a:lnR>
-                    <a:lnT w="9525" cap="flat" cmpd="sng" algn="ctr">
-                      <a:solidFill>
-                        <a:srgbClr val="E2E8F0"/>
-                      </a:solidFill>
-                      <a:prstDash val="solid"/>
-                      <a:round/>
-                      <a:headEnd type="none" w="med" len="med"/>
-                      <a:tailEnd type="none" w="med" len="med"/>
-                    </a:lnT>
-                    <a:lnB w="9525" cap="flat" cmpd="sng" algn="ctr">
-                      <a:solidFill>
-                        <a:srgbClr val="E2E8F0"/>
-                      </a:solidFill>
-                      <a:prstDash val="solid"/>
-                      <a:round/>
-                      <a:headEnd type="none" w="med" len="med"/>
-                      <a:tailEnd type="none" w="med" len="med"/>
-                    </a:lnB>
-                    <a:solidFill>
-                      <a:srgbClr val="004691"/>
-                    </a:solidFill>
-                  </a:tcPr>
-                </a:tc>
-              </a:tr>
-              <a:tr h="667512">
-                <a:tc>
-                  <a:txBody>
-                    <a:bodyPr/>
-                    <a:lstStyle/>
-                    <a:p>
-                      <a:pPr algn="l" indent="0" marL="0">
-                        <a:buNone/>
-                      </a:pPr>
-                      <a:r>
-                        <a:rPr lang="en-US" sz="1300" dirty="0">
-                          <a:solidFill>
-                            <a:srgbClr val="0F172A"/>
-                          </a:solidFill>
-                          <a:latin typeface="Calibri" pitchFamily="34" charset="0"/>
-                          <a:ea typeface="Calibri" pitchFamily="34" charset="-122"/>
-                          <a:cs typeface="Calibri" pitchFamily="34" charset="-120"/>
-                        </a:rPr>
-                        <a:t>Senha do banco protegida</a:t>
-                      </a:r>
-                      <a:endParaRPr lang="en-US" sz="1300" dirty="0">
-                        <a:latin typeface="Calibri" charset="0"/>
-                        <a:ea typeface="Calibri" charset="0"/>
-                        <a:cs typeface="Calibri" charset="0"/>
-                      </a:endParaRPr>
-                    </a:p>
-                  </a:txBody>
-                  <a:tcPr marL="91440" marR="91440" marT="45720" marB="45720" anchor="ctr">
-                    <a:lnL w="9525" cap="flat" cmpd="sng" algn="ctr">
-                      <a:solidFill>
-                        <a:srgbClr val="E2E8F0"/>
-                      </a:solidFill>
-                      <a:prstDash val="solid"/>
-                      <a:round/>
-                      <a:headEnd type="none" w="med" len="med"/>
-                      <a:tailEnd type="none" w="med" len="med"/>
-                    </a:lnL>
-                    <a:lnR w="9525" cap="flat" cmpd="sng" algn="ctr">
-                      <a:solidFill>
-                        <a:srgbClr val="E2E8F0"/>
-                      </a:solidFill>
-                      <a:prstDash val="solid"/>
-                      <a:round/>
-                      <a:headEnd type="none" w="med" len="med"/>
-                      <a:tailEnd type="none" w="med" len="med"/>
-                    </a:lnR>
-                    <a:lnT w="9525" cap="flat" cmpd="sng" algn="ctr">
-                      <a:solidFill>
-                        <a:srgbClr val="E2E8F0"/>
-                      </a:solidFill>
-                      <a:prstDash val="solid"/>
-                      <a:round/>
-                      <a:headEnd type="none" w="med" len="med"/>
-                      <a:tailEnd type="none" w="med" len="med"/>
-                    </a:lnT>
-                    <a:lnB w="9525" cap="flat" cmpd="sng" algn="ctr">
-                      <a:solidFill>
-                        <a:srgbClr val="E2E8F0"/>
-                      </a:solidFill>
-                      <a:prstDash val="solid"/>
-                      <a:round/>
-                      <a:headEnd type="none" w="med" len="med"/>
-                      <a:tailEnd type="none" w="med" len="med"/>
-                    </a:lnB>
-                    <a:solidFill>
-                      <a:srgbClr val="F4F6FA"/>
-                    </a:solidFill>
-                  </a:tcPr>
-                </a:tc>
-                <a:tc>
-                  <a:txBody>
-                    <a:bodyPr/>
-                    <a:lstStyle/>
-                    <a:p>
-                      <a:pPr algn="ctr" indent="0" marL="0">
-                        <a:buNone/>
-                      </a:pPr>
-                      <a:r>
-                        <a:rPr lang="en-US" sz="1300" b="1" dirty="0">
-                          <a:solidFill>
-                            <a:srgbClr val="DC2626"/>
-                          </a:solidFill>
-                          <a:latin typeface="Calibri" pitchFamily="34" charset="0"/>
-                          <a:ea typeface="Calibri" pitchFamily="34" charset="-122"/>
-                          <a:cs typeface="Calibri" pitchFamily="34" charset="-120"/>
-                        </a:rPr>
-                        <a:t>✗</a:t>
-                      </a:r>
-                      <a:endParaRPr lang="en-US" sz="1300" dirty="0">
-                        <a:latin typeface="Calibri" charset="0"/>
-                        <a:ea typeface="Calibri" charset="0"/>
-                        <a:cs typeface="Calibri" charset="0"/>
-                      </a:endParaRPr>
-                    </a:p>
-                  </a:txBody>
-                  <a:tcPr marL="91440" marR="91440" marT="45720" marB="45720" anchor="ctr">
-                    <a:lnL w="9525" cap="flat" cmpd="sng" algn="ctr">
-                      <a:solidFill>
-                        <a:srgbClr val="E2E8F0"/>
-                      </a:solidFill>
-                      <a:prstDash val="solid"/>
-                      <a:round/>
-                      <a:headEnd type="none" w="med" len="med"/>
-                      <a:tailEnd type="none" w="med" len="med"/>
-                    </a:lnL>
-                    <a:lnR w="9525" cap="flat" cmpd="sng" algn="ctr">
-                      <a:solidFill>
-                        <a:srgbClr val="E2E8F0"/>
-                      </a:solidFill>
-                      <a:prstDash val="solid"/>
-                      <a:round/>
-                      <a:headEnd type="none" w="med" len="med"/>
-                      <a:tailEnd type="none" w="med" len="med"/>
-                    </a:lnR>
-                    <a:lnT w="9525" cap="flat" cmpd="sng" algn="ctr">
-                      <a:solidFill>
-                        <a:srgbClr val="E2E8F0"/>
-                      </a:solidFill>
-                      <a:prstDash val="solid"/>
-                      <a:round/>
-                      <a:headEnd type="none" w="med" len="med"/>
-                      <a:tailEnd type="none" w="med" len="med"/>
-                    </a:lnT>
-                    <a:lnB w="9525" cap="flat" cmpd="sng" algn="ctr">
-                      <a:solidFill>
-                        <a:srgbClr val="E2E8F0"/>
-                      </a:solidFill>
-                      <a:prstDash val="solid"/>
-                      <a:round/>
-                      <a:headEnd type="none" w="med" len="med"/>
-                      <a:tailEnd type="none" w="med" len="med"/>
-                    </a:lnB>
-                    <a:solidFill>
-                      <a:srgbClr val="F4F6FA"/>
-                    </a:solidFill>
-                  </a:tcPr>
-                </a:tc>
-                <a:tc>
-                  <a:txBody>
-                    <a:bodyPr/>
-                    <a:lstStyle/>
-                    <a:p>
-                      <a:pPr algn="ctr" indent="0" marL="0">
-                        <a:buNone/>
-                      </a:pPr>
-                      <a:r>
-                        <a:rPr lang="en-US" sz="1300" b="1" dirty="0">
-                          <a:solidFill>
-                            <a:srgbClr val="16A34A"/>
-                          </a:solidFill>
-                          <a:latin typeface="Calibri" pitchFamily="34" charset="0"/>
-                          <a:ea typeface="Calibri" pitchFamily="34" charset="-122"/>
-                          <a:cs typeface="Calibri" pitchFamily="34" charset="-120"/>
-                        </a:rPr>
-                        <a:t>✓</a:t>
-                      </a:r>
-                      <a:endParaRPr lang="en-US" sz="1300" dirty="0">
-                        <a:latin typeface="Calibri" charset="0"/>
-                        <a:ea typeface="Calibri" charset="0"/>
-                        <a:cs typeface="Calibri" charset="0"/>
-                      </a:endParaRPr>
-                    </a:p>
-                  </a:txBody>
-                  <a:tcPr marL="91440" marR="91440" marT="45720" marB="45720" anchor="ctr">
-                    <a:lnL w="9525" cap="flat" cmpd="sng" algn="ctr">
-                      <a:solidFill>
-                        <a:srgbClr val="E2E8F0"/>
-                      </a:solidFill>
-                      <a:prstDash val="solid"/>
-                      <a:round/>
-                      <a:headEnd type="none" w="med" len="med"/>
-                      <a:tailEnd type="none" w="med" len="med"/>
-                    </a:lnL>
-                    <a:lnR w="9525" cap="flat" cmpd="sng" algn="ctr">
-                      <a:solidFill>
-                        <a:srgbClr val="E2E8F0"/>
-                      </a:solidFill>
-                      <a:prstDash val="solid"/>
-                      <a:round/>
-                      <a:headEnd type="none" w="med" len="med"/>
-                      <a:tailEnd type="none" w="med" len="med"/>
-                    </a:lnR>
-                    <a:lnT w="9525" cap="flat" cmpd="sng" algn="ctr">
-                      <a:solidFill>
-                        <a:srgbClr val="E2E8F0"/>
-                      </a:solidFill>
-                      <a:prstDash val="solid"/>
-                      <a:round/>
-                      <a:headEnd type="none" w="med" len="med"/>
-                      <a:tailEnd type="none" w="med" len="med"/>
-                    </a:lnT>
-                    <a:lnB w="9525" cap="flat" cmpd="sng" algn="ctr">
-                      <a:solidFill>
-                        <a:srgbClr val="E2E8F0"/>
-                      </a:solidFill>
-                      <a:prstDash val="solid"/>
-                      <a:round/>
-                      <a:headEnd type="none" w="med" len="med"/>
-                      <a:tailEnd type="none" w="med" len="med"/>
-                    </a:lnB>
-                    <a:solidFill>
-                      <a:srgbClr val="F4F6FA"/>
-                    </a:solidFill>
-                  </a:tcPr>
-                </a:tc>
-              </a:tr>
-              <a:tr h="667512">
-                <a:tc>
-                  <a:txBody>
-                    <a:bodyPr/>
-                    <a:lstStyle/>
-                    <a:p>
-                      <a:pPr algn="l" indent="0" marL="0">
-                        <a:buNone/>
-                      </a:pPr>
-                      <a:r>
-                        <a:rPr lang="en-US" sz="1300" dirty="0">
-                          <a:solidFill>
-                            <a:srgbClr val="0F172A"/>
-                          </a:solidFill>
-                          <a:latin typeface="Calibri" pitchFamily="34" charset="0"/>
-                          <a:ea typeface="Calibri" pitchFamily="34" charset="-122"/>
-                          <a:cs typeface="Calibri" pitchFamily="34" charset="-120"/>
-                        </a:rPr>
-                        <a:t>Mesmo dado sempre com o mesmo resultado</a:t>
-                      </a:r>
-                      <a:endParaRPr lang="en-US" sz="1300" dirty="0">
-                        <a:latin typeface="Calibri" charset="0"/>
-                        <a:ea typeface="Calibri" charset="0"/>
-                        <a:cs typeface="Calibri" charset="0"/>
-                      </a:endParaRPr>
-                    </a:p>
-                  </a:txBody>
-                  <a:tcPr marL="91440" marR="91440" marT="45720" marB="45720" anchor="ctr">
-                    <a:lnL w="9525" cap="flat" cmpd="sng" algn="ctr">
-                      <a:solidFill>
-                        <a:srgbClr val="E2E8F0"/>
-                      </a:solidFill>
-                      <a:prstDash val="solid"/>
-                      <a:round/>
-                      <a:headEnd type="none" w="med" len="med"/>
-                      <a:tailEnd type="none" w="med" len="med"/>
-                    </a:lnL>
-                    <a:lnR w="9525" cap="flat" cmpd="sng" algn="ctr">
-                      <a:solidFill>
-                        <a:srgbClr val="E2E8F0"/>
-                      </a:solidFill>
-                      <a:prstDash val="solid"/>
-                      <a:round/>
-                      <a:headEnd type="none" w="med" len="med"/>
-                      <a:tailEnd type="none" w="med" len="med"/>
-                    </a:lnR>
-                    <a:lnT w="9525" cap="flat" cmpd="sng" algn="ctr">
-                      <a:solidFill>
-                        <a:srgbClr val="E2E8F0"/>
-                      </a:solidFill>
-                      <a:prstDash val="solid"/>
-                      <a:round/>
-                      <a:headEnd type="none" w="med" len="med"/>
-                      <a:tailEnd type="none" w="med" len="med"/>
-                    </a:lnT>
-                    <a:lnB w="9525" cap="flat" cmpd="sng" algn="ctr">
-                      <a:solidFill>
-                        <a:srgbClr val="E2E8F0"/>
-                      </a:solidFill>
-                      <a:prstDash val="solid"/>
-                      <a:round/>
-                      <a:headEnd type="none" w="med" len="med"/>
-                      <a:tailEnd type="none" w="med" len="med"/>
-                    </a:lnB>
-                    <a:solidFill>
-                      <a:srgbClr val="FFFFFF"/>
-                    </a:solidFill>
-                  </a:tcPr>
-                </a:tc>
-                <a:tc>
-                  <a:txBody>
-                    <a:bodyPr/>
-                    <a:lstStyle/>
-                    <a:p>
-                      <a:pPr algn="ctr" indent="0" marL="0">
-                        <a:buNone/>
-                      </a:pPr>
-                      <a:r>
-                        <a:rPr lang="en-US" sz="1300" b="1" dirty="0">
-                          <a:solidFill>
-                            <a:srgbClr val="DC2626"/>
-                          </a:solidFill>
-                          <a:latin typeface="Calibri" pitchFamily="34" charset="0"/>
-                          <a:ea typeface="Calibri" pitchFamily="34" charset="-122"/>
-                          <a:cs typeface="Calibri" pitchFamily="34" charset="-120"/>
-                        </a:rPr>
-                        <a:t>✗</a:t>
-                      </a:r>
-                      <a:endParaRPr lang="en-US" sz="1300" dirty="0">
-                        <a:latin typeface="Calibri" charset="0"/>
-                        <a:ea typeface="Calibri" charset="0"/>
-                        <a:cs typeface="Calibri" charset="0"/>
-                      </a:endParaRPr>
-                    </a:p>
-                  </a:txBody>
-                  <a:tcPr marL="91440" marR="91440" marT="45720" marB="45720" anchor="ctr">
-                    <a:lnL w="9525" cap="flat" cmpd="sng" algn="ctr">
-                      <a:solidFill>
-                        <a:srgbClr val="E2E8F0"/>
-                      </a:solidFill>
-                      <a:prstDash val="solid"/>
-                      <a:round/>
-                      <a:headEnd type="none" w="med" len="med"/>
-                      <a:tailEnd type="none" w="med" len="med"/>
-                    </a:lnL>
-                    <a:lnR w="9525" cap="flat" cmpd="sng" algn="ctr">
-                      <a:solidFill>
-                        <a:srgbClr val="E2E8F0"/>
-                      </a:solidFill>
-                      <a:prstDash val="solid"/>
-                      <a:round/>
-                      <a:headEnd type="none" w="med" len="med"/>
-                      <a:tailEnd type="none" w="med" len="med"/>
-                    </a:lnR>
-                    <a:lnT w="9525" cap="flat" cmpd="sng" algn="ctr">
-                      <a:solidFill>
-                        <a:srgbClr val="E2E8F0"/>
-                      </a:solidFill>
-                      <a:prstDash val="solid"/>
-                      <a:round/>
-                      <a:headEnd type="none" w="med" len="med"/>
-                      <a:tailEnd type="none" w="med" len="med"/>
-                    </a:lnT>
-                    <a:lnB w="9525" cap="flat" cmpd="sng" algn="ctr">
-                      <a:solidFill>
-                        <a:srgbClr val="E2E8F0"/>
-                      </a:solidFill>
-                      <a:prstDash val="solid"/>
-                      <a:round/>
-                      <a:headEnd type="none" w="med" len="med"/>
-                      <a:tailEnd type="none" w="med" len="med"/>
-                    </a:lnB>
-                    <a:solidFill>
-                      <a:srgbClr val="FFFFFF"/>
-                    </a:solidFill>
-                  </a:tcPr>
-                </a:tc>
-                <a:tc>
-                  <a:txBody>
-                    <a:bodyPr/>
-                    <a:lstStyle/>
-                    <a:p>
-                      <a:pPr algn="ctr" indent="0" marL="0">
-                        <a:buNone/>
-                      </a:pPr>
-                      <a:r>
-                        <a:rPr lang="en-US" sz="1300" b="1" dirty="0">
-                          <a:solidFill>
-                            <a:srgbClr val="16A34A"/>
-                          </a:solidFill>
-                          <a:latin typeface="Calibri" pitchFamily="34" charset="0"/>
-                          <a:ea typeface="Calibri" pitchFamily="34" charset="-122"/>
-                          <a:cs typeface="Calibri" pitchFamily="34" charset="-120"/>
-                        </a:rPr>
-                        <a:t>✓</a:t>
-                      </a:r>
-                      <a:endParaRPr lang="en-US" sz="1300" dirty="0">
-                        <a:latin typeface="Calibri" charset="0"/>
-                        <a:ea typeface="Calibri" charset="0"/>
-                        <a:cs typeface="Calibri" charset="0"/>
-                      </a:endParaRPr>
-                    </a:p>
-                  </a:txBody>
-                  <a:tcPr marL="91440" marR="91440" marT="45720" marB="45720" anchor="ctr">
-                    <a:lnL w="9525" cap="flat" cmpd="sng" algn="ctr">
-                      <a:solidFill>
-                        <a:srgbClr val="E2E8F0"/>
-                      </a:solidFill>
-                      <a:prstDash val="solid"/>
-                      <a:round/>
-                      <a:headEnd type="none" w="med" len="med"/>
-                      <a:tailEnd type="none" w="med" len="med"/>
-                    </a:lnL>
-                    <a:lnR w="9525" cap="flat" cmpd="sng" algn="ctr">
-                      <a:solidFill>
-                        <a:srgbClr val="E2E8F0"/>
-                      </a:solidFill>
-                      <a:prstDash val="solid"/>
-                      <a:round/>
-                      <a:headEnd type="none" w="med" len="med"/>
-                      <a:tailEnd type="none" w="med" len="med"/>
-                    </a:lnR>
-                    <a:lnT w="9525" cap="flat" cmpd="sng" algn="ctr">
-                      <a:solidFill>
-                        <a:srgbClr val="E2E8F0"/>
-                      </a:solidFill>
-                      <a:prstDash val="solid"/>
-                      <a:round/>
-                      <a:headEnd type="none" w="med" len="med"/>
-                      <a:tailEnd type="none" w="med" len="med"/>
-                    </a:lnT>
-                    <a:lnB w="9525" cap="flat" cmpd="sng" algn="ctr">
-                      <a:solidFill>
-                        <a:srgbClr val="E2E8F0"/>
-                      </a:solidFill>
-                      <a:prstDash val="solid"/>
-                      <a:round/>
-                      <a:headEnd type="none" w="med" len="med"/>
-                      <a:tailEnd type="none" w="med" len="med"/>
-                    </a:lnB>
-                    <a:solidFill>
-                      <a:srgbClr val="FFFFFF"/>
-                    </a:solidFill>
-                  </a:tcPr>
-                </a:tc>
-              </a:tr>
-              <a:tr h="667512">
-                <a:tc>
-                  <a:txBody>
-                    <a:bodyPr/>
-                    <a:lstStyle/>
-                    <a:p>
-                      <a:pPr algn="l" indent="0" marL="0">
-                        <a:buNone/>
-                      </a:pPr>
-                      <a:r>
-                        <a:rPr lang="en-US" sz="1300" dirty="0">
-                          <a:solidFill>
-                            <a:srgbClr val="0F172A"/>
-                          </a:solidFill>
-                          <a:latin typeface="Calibri" pitchFamily="34" charset="0"/>
-                          <a:ea typeface="Calibri" pitchFamily="34" charset="-122"/>
-                          <a:cs typeface="Calibri" pitchFamily="34" charset="-120"/>
-                        </a:rPr>
-                        <a:t>Progresso visível, sem travar</a:t>
-                      </a:r>
-                      <a:endParaRPr lang="en-US" sz="1300" dirty="0">
-                        <a:latin typeface="Calibri" charset="0"/>
-                        <a:ea typeface="Calibri" charset="0"/>
-                        <a:cs typeface="Calibri" charset="0"/>
-                      </a:endParaRPr>
-                    </a:p>
-                  </a:txBody>
-                  <a:tcPr marL="91440" marR="91440" marT="45720" marB="45720" anchor="ctr">
-                    <a:lnL w="9525" cap="flat" cmpd="sng" algn="ctr">
-                      <a:solidFill>
-                        <a:srgbClr val="E2E8F0"/>
-                      </a:solidFill>
-                      <a:prstDash val="solid"/>
-                      <a:round/>
-                      <a:headEnd type="none" w="med" len="med"/>
-                      <a:tailEnd type="none" w="med" len="med"/>
-                    </a:lnL>
-                    <a:lnR w="9525" cap="flat" cmpd="sng" algn="ctr">
-                      <a:solidFill>
-                        <a:srgbClr val="E2E8F0"/>
-                      </a:solidFill>
-                      <a:prstDash val="solid"/>
-                      <a:round/>
-                      <a:headEnd type="none" w="med" len="med"/>
-                      <a:tailEnd type="none" w="med" len="med"/>
-                    </a:lnR>
-                    <a:lnT w="9525" cap="flat" cmpd="sng" algn="ctr">
-                      <a:solidFill>
-                        <a:srgbClr val="E2E8F0"/>
-                      </a:solidFill>
-                      <a:prstDash val="solid"/>
-                      <a:round/>
-                      <a:headEnd type="none" w="med" len="med"/>
-                      <a:tailEnd type="none" w="med" len="med"/>
-                    </a:lnT>
-                    <a:lnB w="9525" cap="flat" cmpd="sng" algn="ctr">
-                      <a:solidFill>
-                        <a:srgbClr val="E2E8F0"/>
-                      </a:solidFill>
-                      <a:prstDash val="solid"/>
-                      <a:round/>
-                      <a:headEnd type="none" w="med" len="med"/>
-                      <a:tailEnd type="none" w="med" len="med"/>
-                    </a:lnB>
-                    <a:solidFill>
-                      <a:srgbClr val="F4F6FA"/>
-                    </a:solidFill>
-                  </a:tcPr>
-                </a:tc>
-                <a:tc>
-                  <a:txBody>
-                    <a:bodyPr/>
-                    <a:lstStyle/>
-                    <a:p>
-                      <a:pPr algn="ctr" indent="0" marL="0">
-                        <a:buNone/>
-                      </a:pPr>
-                      <a:r>
-                        <a:rPr lang="en-US" sz="1300" b="1" dirty="0">
-                          <a:solidFill>
-                            <a:srgbClr val="DC2626"/>
-                          </a:solidFill>
-                          <a:latin typeface="Calibri" pitchFamily="34" charset="0"/>
-                          <a:ea typeface="Calibri" pitchFamily="34" charset="-122"/>
-                          <a:cs typeface="Calibri" pitchFamily="34" charset="-120"/>
-                        </a:rPr>
-                        <a:t>✗</a:t>
-                      </a:r>
-                      <a:endParaRPr lang="en-US" sz="1300" dirty="0">
-                        <a:latin typeface="Calibri" charset="0"/>
-                        <a:ea typeface="Calibri" charset="0"/>
-                        <a:cs typeface="Calibri" charset="0"/>
-                      </a:endParaRPr>
-                    </a:p>
-                  </a:txBody>
-                  <a:tcPr marL="91440" marR="91440" marT="45720" marB="45720" anchor="ctr">
-                    <a:lnL w="9525" cap="flat" cmpd="sng" algn="ctr">
-                      <a:solidFill>
-                        <a:srgbClr val="E2E8F0"/>
-                      </a:solidFill>
-                      <a:prstDash val="solid"/>
-                      <a:round/>
-                      <a:headEnd type="none" w="med" len="med"/>
-                      <a:tailEnd type="none" w="med" len="med"/>
-                    </a:lnL>
-                    <a:lnR w="9525" cap="flat" cmpd="sng" algn="ctr">
-                      <a:solidFill>
-                        <a:srgbClr val="E2E8F0"/>
-                      </a:solidFill>
-                      <a:prstDash val="solid"/>
-                      <a:round/>
-                      <a:headEnd type="none" w="med" len="med"/>
-                      <a:tailEnd type="none" w="med" len="med"/>
-                    </a:lnR>
-                    <a:lnT w="9525" cap="flat" cmpd="sng" algn="ctr">
-                      <a:solidFill>
-                        <a:srgbClr val="E2E8F0"/>
-                      </a:solidFill>
-                      <a:prstDash val="solid"/>
-                      <a:round/>
-                      <a:headEnd type="none" w="med" len="med"/>
-                      <a:tailEnd type="none" w="med" len="med"/>
-                    </a:lnT>
-                    <a:lnB w="9525" cap="flat" cmpd="sng" algn="ctr">
-                      <a:solidFill>
-                        <a:srgbClr val="E2E8F0"/>
-                      </a:solidFill>
-                      <a:prstDash val="solid"/>
-                      <a:round/>
-                      <a:headEnd type="none" w="med" len="med"/>
-                      <a:tailEnd type="none" w="med" len="med"/>
-                    </a:lnB>
-                    <a:solidFill>
-                      <a:srgbClr val="F4F6FA"/>
-                    </a:solidFill>
-                  </a:tcPr>
-                </a:tc>
-                <a:tc>
-                  <a:txBody>
-                    <a:bodyPr/>
-                    <a:lstStyle/>
-                    <a:p>
-                      <a:pPr algn="ctr" indent="0" marL="0">
-                        <a:buNone/>
-                      </a:pPr>
-                      <a:r>
-                        <a:rPr lang="en-US" sz="1300" b="1" dirty="0">
-                          <a:solidFill>
-                            <a:srgbClr val="16A34A"/>
-                          </a:solidFill>
-                          <a:latin typeface="Calibri" pitchFamily="34" charset="0"/>
-                          <a:ea typeface="Calibri" pitchFamily="34" charset="-122"/>
-                          <a:cs typeface="Calibri" pitchFamily="34" charset="-120"/>
-                        </a:rPr>
-                        <a:t>✓</a:t>
-                      </a:r>
-                      <a:endParaRPr lang="en-US" sz="1300" dirty="0">
-                        <a:latin typeface="Calibri" charset="0"/>
-                        <a:ea typeface="Calibri" charset="0"/>
-                        <a:cs typeface="Calibri" charset="0"/>
-                      </a:endParaRPr>
-                    </a:p>
-                  </a:txBody>
-                  <a:tcPr marL="91440" marR="91440" marT="45720" marB="45720" anchor="ctr">
-                    <a:lnL w="9525" cap="flat" cmpd="sng" algn="ctr">
-                      <a:solidFill>
-                        <a:srgbClr val="E2E8F0"/>
-                      </a:solidFill>
-                      <a:prstDash val="solid"/>
-                      <a:round/>
-                      <a:headEnd type="none" w="med" len="med"/>
-                      <a:tailEnd type="none" w="med" len="med"/>
-                    </a:lnL>
-                    <a:lnR w="9525" cap="flat" cmpd="sng" algn="ctr">
-                      <a:solidFill>
-                        <a:srgbClr val="E2E8F0"/>
-                      </a:solidFill>
-                      <a:prstDash val="solid"/>
-                      <a:round/>
-                      <a:headEnd type="none" w="med" len="med"/>
-                      <a:tailEnd type="none" w="med" len="med"/>
-                    </a:lnR>
-                    <a:lnT w="9525" cap="flat" cmpd="sng" algn="ctr">
-                      <a:solidFill>
-                        <a:srgbClr val="E2E8F0"/>
-                      </a:solidFill>
-                      <a:prstDash val="solid"/>
-                      <a:round/>
-                      <a:headEnd type="none" w="med" len="med"/>
-                      <a:tailEnd type="none" w="med" len="med"/>
-                    </a:lnT>
-                    <a:lnB w="9525" cap="flat" cmpd="sng" algn="ctr">
-                      <a:solidFill>
-                        <a:srgbClr val="E2E8F0"/>
-                      </a:solidFill>
-                      <a:prstDash val="solid"/>
-                      <a:round/>
-                      <a:headEnd type="none" w="med" len="med"/>
-                      <a:tailEnd type="none" w="med" len="med"/>
-                    </a:lnB>
-                    <a:solidFill>
-                      <a:srgbClr val="F4F6FA"/>
-                    </a:solidFill>
-                  </a:tcPr>
-                </a:tc>
-              </a:tr>
-              <a:tr h="667512">
-                <a:tc>
-                  <a:txBody>
-                    <a:bodyPr/>
-                    <a:lstStyle/>
-                    <a:p>
-                      <a:pPr algn="l" indent="0" marL="0">
-                        <a:buNone/>
-                      </a:pPr>
-                      <a:r>
-                        <a:rPr lang="en-US" sz="1300" dirty="0">
-                          <a:solidFill>
-                            <a:srgbClr val="0F172A"/>
-                          </a:solidFill>
-                          <a:latin typeface="Calibri" pitchFamily="34" charset="0"/>
-                          <a:ea typeface="Calibri" pitchFamily="34" charset="-122"/>
-                          <a:cs typeface="Calibri" pitchFamily="34" charset="-120"/>
-                        </a:rPr>
-                        <a:t>Depende de poucas pessoas para manter</a:t>
-                      </a:r>
-                      <a:endParaRPr lang="en-US" sz="1300" dirty="0">
-                        <a:latin typeface="Calibri" charset="0"/>
-                        <a:ea typeface="Calibri" charset="0"/>
-                        <a:cs typeface="Calibri" charset="0"/>
-                      </a:endParaRPr>
-                    </a:p>
-                  </a:txBody>
-                  <a:tcPr marL="91440" marR="91440" marT="45720" marB="45720" anchor="ctr">
-                    <a:lnL w="9525" cap="flat" cmpd="sng" algn="ctr">
-                      <a:solidFill>
-                        <a:srgbClr val="E2E8F0"/>
-                      </a:solidFill>
-                      <a:prstDash val="solid"/>
-                      <a:round/>
-                      <a:headEnd type="none" w="med" len="med"/>
-                      <a:tailEnd type="none" w="med" len="med"/>
-                    </a:lnL>
-                    <a:lnR w="9525" cap="flat" cmpd="sng" algn="ctr">
-                      <a:solidFill>
-                        <a:srgbClr val="E2E8F0"/>
-                      </a:solidFill>
-                      <a:prstDash val="solid"/>
-                      <a:round/>
-                      <a:headEnd type="none" w="med" len="med"/>
-                      <a:tailEnd type="none" w="med" len="med"/>
-                    </a:lnR>
-                    <a:lnT w="9525" cap="flat" cmpd="sng" algn="ctr">
-                      <a:solidFill>
-                        <a:srgbClr val="E2E8F0"/>
-                      </a:solidFill>
-                      <a:prstDash val="solid"/>
-                      <a:round/>
-                      <a:headEnd type="none" w="med" len="med"/>
-                      <a:tailEnd type="none" w="med" len="med"/>
-                    </a:lnT>
-                    <a:lnB w="9525" cap="flat" cmpd="sng" algn="ctr">
-                      <a:solidFill>
-                        <a:srgbClr val="E2E8F0"/>
-                      </a:solidFill>
-                      <a:prstDash val="solid"/>
-                      <a:round/>
-                      <a:headEnd type="none" w="med" len="med"/>
-                      <a:tailEnd type="none" w="med" len="med"/>
-                    </a:lnB>
-                    <a:solidFill>
-                      <a:srgbClr val="FFFFFF"/>
-                    </a:solidFill>
-                  </a:tcPr>
-                </a:tc>
-                <a:tc>
-                  <a:txBody>
-                    <a:bodyPr/>
-                    <a:lstStyle/>
-                    <a:p>
-                      <a:pPr algn="ctr" indent="0" marL="0">
-                        <a:buNone/>
-                      </a:pPr>
-                      <a:r>
-                        <a:rPr lang="en-US" sz="1300" b="1" dirty="0">
-                          <a:solidFill>
-                            <a:srgbClr val="DC2626"/>
-                          </a:solidFill>
-                          <a:latin typeface="Calibri" pitchFamily="34" charset="0"/>
-                          <a:ea typeface="Calibri" pitchFamily="34" charset="-122"/>
-                          <a:cs typeface="Calibri" pitchFamily="34" charset="-120"/>
-                        </a:rPr>
-                        <a:t>✗</a:t>
-                      </a:r>
-                      <a:endParaRPr lang="en-US" sz="1300" dirty="0">
-                        <a:latin typeface="Calibri" charset="0"/>
-                        <a:ea typeface="Calibri" charset="0"/>
-                        <a:cs typeface="Calibri" charset="0"/>
-                      </a:endParaRPr>
-                    </a:p>
-                  </a:txBody>
-                  <a:tcPr marL="91440" marR="91440" marT="45720" marB="45720" anchor="ctr">
-                    <a:lnL w="9525" cap="flat" cmpd="sng" algn="ctr">
-                      <a:solidFill>
-                        <a:srgbClr val="E2E8F0"/>
-                      </a:solidFill>
-                      <a:prstDash val="solid"/>
-                      <a:round/>
-                      <a:headEnd type="none" w="med" len="med"/>
-                      <a:tailEnd type="none" w="med" len="med"/>
-                    </a:lnL>
-                    <a:lnR w="9525" cap="flat" cmpd="sng" algn="ctr">
-                      <a:solidFill>
-                        <a:srgbClr val="E2E8F0"/>
-                      </a:solidFill>
-                      <a:prstDash val="solid"/>
-                      <a:round/>
-                      <a:headEnd type="none" w="med" len="med"/>
-                      <a:tailEnd type="none" w="med" len="med"/>
-                    </a:lnR>
-                    <a:lnT w="9525" cap="flat" cmpd="sng" algn="ctr">
-                      <a:solidFill>
-                        <a:srgbClr val="E2E8F0"/>
-                      </a:solidFill>
-                      <a:prstDash val="solid"/>
-                      <a:round/>
-                      <a:headEnd type="none" w="med" len="med"/>
-                      <a:tailEnd type="none" w="med" len="med"/>
-                    </a:lnT>
-                    <a:lnB w="9525" cap="flat" cmpd="sng" algn="ctr">
-                      <a:solidFill>
-                        <a:srgbClr val="E2E8F0"/>
-                      </a:solidFill>
-                      <a:prstDash val="solid"/>
-                      <a:round/>
-                      <a:headEnd type="none" w="med" len="med"/>
-                      <a:tailEnd type="none" w="med" len="med"/>
-                    </a:lnB>
-                    <a:solidFill>
-                      <a:srgbClr val="FFFFFF"/>
-                    </a:solidFill>
-                  </a:tcPr>
-                </a:tc>
-                <a:tc>
-                  <a:txBody>
-                    <a:bodyPr/>
-                    <a:lstStyle/>
-                    <a:p>
-                      <a:pPr algn="ctr" indent="0" marL="0">
-                        <a:buNone/>
-                      </a:pPr>
-                      <a:r>
-                        <a:rPr lang="en-US" sz="1300" b="1" dirty="0">
-                          <a:solidFill>
-                            <a:srgbClr val="16A34A"/>
-                          </a:solidFill>
-                          <a:latin typeface="Calibri" pitchFamily="34" charset="0"/>
-                          <a:ea typeface="Calibri" pitchFamily="34" charset="-122"/>
-                          <a:cs typeface="Calibri" pitchFamily="34" charset="-120"/>
-                        </a:rPr>
-                        <a:t>✓</a:t>
-                      </a:r>
-                      <a:endParaRPr lang="en-US" sz="1300" dirty="0">
-                        <a:latin typeface="Calibri" charset="0"/>
-                        <a:ea typeface="Calibri" charset="0"/>
-                        <a:cs typeface="Calibri" charset="0"/>
-                      </a:endParaRPr>
-                    </a:p>
-                  </a:txBody>
-                  <a:tcPr marL="91440" marR="91440" marT="45720" marB="45720" anchor="ctr">
-                    <a:lnL w="9525" cap="flat" cmpd="sng" algn="ctr">
-                      <a:solidFill>
-                        <a:srgbClr val="E2E8F0"/>
-                      </a:solidFill>
-                      <a:prstDash val="solid"/>
-                      <a:round/>
-                      <a:headEnd type="none" w="med" len="med"/>
-                      <a:tailEnd type="none" w="med" len="med"/>
-                    </a:lnL>
-                    <a:lnR w="9525" cap="flat" cmpd="sng" algn="ctr">
-                      <a:solidFill>
-                        <a:srgbClr val="E2E8F0"/>
-                      </a:solidFill>
-                      <a:prstDash val="solid"/>
-                      <a:round/>
-                      <a:headEnd type="none" w="med" len="med"/>
-                      <a:tailEnd type="none" w="med" len="med"/>
-                    </a:lnR>
-                    <a:lnT w="9525" cap="flat" cmpd="sng" algn="ctr">
-                      <a:solidFill>
-                        <a:srgbClr val="E2E8F0"/>
-                      </a:solidFill>
-                      <a:prstDash val="solid"/>
-                      <a:round/>
-                      <a:headEnd type="none" w="med" len="med"/>
-                      <a:tailEnd type="none" w="med" len="med"/>
-                    </a:lnT>
-                    <a:lnB w="9525" cap="flat" cmpd="sng" algn="ctr">
-                      <a:solidFill>
-                        <a:srgbClr val="E2E8F0"/>
-                      </a:solidFill>
-                      <a:prstDash val="solid"/>
-                      <a:round/>
-                      <a:headEnd type="none" w="med" len="med"/>
-                      <a:tailEnd type="none" w="med" len="med"/>
-                    </a:lnB>
-                    <a:solidFill>
-                      <a:srgbClr val="FFFFFF"/>
-                    </a:solidFill>
-                  </a:tcPr>
-                </a:tc>
-              </a:tr>
-              <a:tr h="667512">
-                <a:tc>
-                  <a:txBody>
-                    <a:bodyPr/>
-                    <a:lstStyle/>
-                    <a:p>
-                      <a:pPr algn="l" indent="0" marL="0">
-                        <a:buNone/>
-                      </a:pPr>
-                      <a:r>
-                        <a:rPr lang="en-US" sz="1300" dirty="0">
-                          <a:solidFill>
-                            <a:srgbClr val="0F172A"/>
-                          </a:solidFill>
-                          <a:latin typeface="Calibri" pitchFamily="34" charset="0"/>
-                          <a:ea typeface="Calibri" pitchFamily="34" charset="-122"/>
-                          <a:cs typeface="Calibri" pitchFamily="34" charset="-120"/>
-                        </a:rPr>
-                        <a:t>Mudanças testáveis antes de ir pro ar</a:t>
-                      </a:r>
-                      <a:endParaRPr lang="en-US" sz="1300" dirty="0">
-                        <a:latin typeface="Calibri" charset="0"/>
-                        <a:ea typeface="Calibri" charset="0"/>
-                        <a:cs typeface="Calibri" charset="0"/>
-                      </a:endParaRPr>
-                    </a:p>
-                  </a:txBody>
-                  <a:tcPr marL="91440" marR="91440" marT="45720" marB="45720" anchor="ctr">
-                    <a:lnL w="9525" cap="flat" cmpd="sng" algn="ctr">
-                      <a:solidFill>
-                        <a:srgbClr val="E2E8F0"/>
-                      </a:solidFill>
-                      <a:prstDash val="solid"/>
-                      <a:round/>
-                      <a:headEnd type="none" w="med" len="med"/>
-                      <a:tailEnd type="none" w="med" len="med"/>
-                    </a:lnL>
-                    <a:lnR w="9525" cap="flat" cmpd="sng" algn="ctr">
-                      <a:solidFill>
-                        <a:srgbClr val="E2E8F0"/>
-                      </a:solidFill>
-                      <a:prstDash val="solid"/>
-                      <a:round/>
-                      <a:headEnd type="none" w="med" len="med"/>
-                      <a:tailEnd type="none" w="med" len="med"/>
-                    </a:lnR>
-                    <a:lnT w="9525" cap="flat" cmpd="sng" algn="ctr">
-                      <a:solidFill>
-                        <a:srgbClr val="E2E8F0"/>
-                      </a:solidFill>
-                      <a:prstDash val="solid"/>
-                      <a:round/>
-                      <a:headEnd type="none" w="med" len="med"/>
-                      <a:tailEnd type="none" w="med" len="med"/>
-                    </a:lnT>
-                    <a:lnB w="9525" cap="flat" cmpd="sng" algn="ctr">
-                      <a:solidFill>
-                        <a:srgbClr val="E2E8F0"/>
-                      </a:solidFill>
-                      <a:prstDash val="solid"/>
-                      <a:round/>
-                      <a:headEnd type="none" w="med" len="med"/>
-                      <a:tailEnd type="none" w="med" len="med"/>
-                    </a:lnB>
-                    <a:solidFill>
-                      <a:srgbClr val="F4F6FA"/>
-                    </a:solidFill>
-                  </a:tcPr>
-                </a:tc>
-                <a:tc>
-                  <a:txBody>
-                    <a:bodyPr/>
-                    <a:lstStyle/>
-                    <a:p>
-                      <a:pPr algn="ctr" indent="0" marL="0">
-                        <a:buNone/>
-                      </a:pPr>
-                      <a:r>
-                        <a:rPr lang="en-US" sz="1300" b="1" dirty="0">
-                          <a:solidFill>
-                            <a:srgbClr val="DC2626"/>
-                          </a:solidFill>
-                          <a:latin typeface="Calibri" pitchFamily="34" charset="0"/>
-                          <a:ea typeface="Calibri" pitchFamily="34" charset="-122"/>
-                          <a:cs typeface="Calibri" pitchFamily="34" charset="-120"/>
-                        </a:rPr>
-                        <a:t>✗</a:t>
-                      </a:r>
-                      <a:endParaRPr lang="en-US" sz="1300" dirty="0">
-                        <a:latin typeface="Calibri" charset="0"/>
-                        <a:ea typeface="Calibri" charset="0"/>
-                        <a:cs typeface="Calibri" charset="0"/>
-                      </a:endParaRPr>
-                    </a:p>
-                  </a:txBody>
-                  <a:tcPr marL="91440" marR="91440" marT="45720" marB="45720" anchor="ctr">
-                    <a:lnL w="9525" cap="flat" cmpd="sng" algn="ctr">
-                      <a:solidFill>
-                        <a:srgbClr val="E2E8F0"/>
-                      </a:solidFill>
-                      <a:prstDash val="solid"/>
-                      <a:round/>
-                      <a:headEnd type="none" w="med" len="med"/>
-                      <a:tailEnd type="none" w="med" len="med"/>
-                    </a:lnL>
-                    <a:lnR w="9525" cap="flat" cmpd="sng" algn="ctr">
-                      <a:solidFill>
-                        <a:srgbClr val="E2E8F0"/>
-                      </a:solidFill>
-                      <a:prstDash val="solid"/>
-                      <a:round/>
-                      <a:headEnd type="none" w="med" len="med"/>
-                      <a:tailEnd type="none" w="med" len="med"/>
-                    </a:lnR>
-                    <a:lnT w="9525" cap="flat" cmpd="sng" algn="ctr">
-                      <a:solidFill>
-                        <a:srgbClr val="E2E8F0"/>
-                      </a:solidFill>
-                      <a:prstDash val="solid"/>
-                      <a:round/>
-                      <a:headEnd type="none" w="med" len="med"/>
-                      <a:tailEnd type="none" w="med" len="med"/>
-                    </a:lnT>
-                    <a:lnB w="9525" cap="flat" cmpd="sng" algn="ctr">
-                      <a:solidFill>
-                        <a:srgbClr val="E2E8F0"/>
-                      </a:solidFill>
-                      <a:prstDash val="solid"/>
-                      <a:round/>
-                      <a:headEnd type="none" w="med" len="med"/>
-                      <a:tailEnd type="none" w="med" len="med"/>
-                    </a:lnB>
-                    <a:solidFill>
-                      <a:srgbClr val="F4F6FA"/>
-                    </a:solidFill>
-                  </a:tcPr>
-                </a:tc>
-                <a:tc>
-                  <a:txBody>
-                    <a:bodyPr/>
-                    <a:lstStyle/>
-                    <a:p>
-                      <a:pPr algn="ctr" indent="0" marL="0">
-                        <a:buNone/>
-                      </a:pPr>
-                      <a:r>
-                        <a:rPr lang="en-US" sz="1300" b="1" dirty="0">
-                          <a:solidFill>
-                            <a:srgbClr val="16A34A"/>
-                          </a:solidFill>
-                          <a:latin typeface="Calibri" pitchFamily="34" charset="0"/>
-                          <a:ea typeface="Calibri" pitchFamily="34" charset="-122"/>
-                          <a:cs typeface="Calibri" pitchFamily="34" charset="-120"/>
-                        </a:rPr>
-                        <a:t>✓</a:t>
-                      </a:r>
-                      <a:endParaRPr lang="en-US" sz="1300" dirty="0">
-                        <a:latin typeface="Calibri" charset="0"/>
-                        <a:ea typeface="Calibri" charset="0"/>
-                        <a:cs typeface="Calibri" charset="0"/>
-                      </a:endParaRPr>
-                    </a:p>
-                  </a:txBody>
-                  <a:tcPr marL="91440" marR="91440" marT="45720" marB="45720" anchor="ctr">
-                    <a:lnL w="9525" cap="flat" cmpd="sng" algn="ctr">
-                      <a:solidFill>
-                        <a:srgbClr val="E2E8F0"/>
-                      </a:solidFill>
-                      <a:prstDash val="solid"/>
-                      <a:round/>
-                      <a:headEnd type="none" w="med" len="med"/>
-                      <a:tailEnd type="none" w="med" len="med"/>
-                    </a:lnL>
-                    <a:lnR w="9525" cap="flat" cmpd="sng" algn="ctr">
-                      <a:solidFill>
-                        <a:srgbClr val="E2E8F0"/>
-                      </a:solidFill>
-                      <a:prstDash val="solid"/>
-                      <a:round/>
-                      <a:headEnd type="none" w="med" len="med"/>
-                      <a:tailEnd type="none" w="med" len="med"/>
-                    </a:lnR>
-                    <a:lnT w="9525" cap="flat" cmpd="sng" algn="ctr">
-                      <a:solidFill>
-                        <a:srgbClr val="E2E8F0"/>
-                      </a:solidFill>
-                      <a:prstDash val="solid"/>
-                      <a:round/>
-                      <a:headEnd type="none" w="med" len="med"/>
-                      <a:tailEnd type="none" w="med" len="med"/>
-                    </a:lnT>
-                    <a:lnB w="9525" cap="flat" cmpd="sng" algn="ctr">
-                      <a:solidFill>
-                        <a:srgbClr val="E2E8F0"/>
-                      </a:solidFill>
-                      <a:prstDash val="solid"/>
-                      <a:round/>
-                      <a:headEnd type="none" w="med" len="med"/>
-                      <a:tailEnd type="none" w="med" len="med"/>
-                    </a:lnB>
-                    <a:solidFill>
-                      <a:srgbClr val="F4F6FA"/>
-                    </a:solidFill>
-                  </a:tcPr>
-                </a:tc>
-              </a:tr>
-            </a:tbl>
-          </a:graphicData>
-        </a:graphic>
-      </p:graphicFrame>
-      <p:sp>
-        <p:nvSpPr>
-          <p:cNvPr id="5" name="Text 2"/>
+      <p:sp>
+        <p:nvSpPr>
+          <p:cNvPr id="4" name="Shape 2"/>
+          <p:cNvSpPr/>
+          <p:nvPr/>
+        </p:nvSpPr>
+        <p:spPr>
+          <a:xfrm>
+            <a:off x="548640" y="1554480"/>
+            <a:ext cx="3931920" cy="1554480"/>
+          </a:xfrm>
+          <a:prstGeom prst="roundRect">
+            <a:avLst>
+              <a:gd name="adj" fmla="val 4706"/>
+            </a:avLst>
+          </a:prstGeom>
+          <a:solidFill>
+            <a:srgbClr val="F4F6FA"/>
+          </a:solidFill>
+          <a:ln/>
+        </p:spPr>
+      </p:sp>
+      <p:sp>
+        <p:nvSpPr>
+          <p:cNvPr id="5" name="Text 3"/>
+          <p:cNvSpPr/>
+          <p:nvPr/>
+        </p:nvSpPr>
+        <p:spPr>
+          <a:xfrm>
+            <a:off x="822960" y="1691640"/>
+            <a:ext cx="3383280" cy="777240"/>
+          </a:xfrm>
+          <a:prstGeom prst="rect">
+            <a:avLst/>
+          </a:prstGeom>
+          <a:noFill/>
+          <a:ln/>
+        </p:spPr>
+        <p:txBody>
+          <a:bodyPr wrap="square" lIns="0" tIns="0" rIns="0" bIns="0" rtlCol="0" anchor="ctr"/>
+          <a:lstStyle/>
+          <a:p>
+            <a:pPr indent="0" marL="0">
+              <a:buNone/>
+            </a:pPr>
+            <a:r>
+              <a:rPr lang="en-US" sz="4600" b="1" dirty="0">
+                <a:solidFill>
+                  <a:srgbClr val="004691"/>
+                </a:solidFill>
+                <a:latin typeface="Calibri" pitchFamily="34" charset="0"/>
+                <a:ea typeface="Calibri" pitchFamily="34" charset="-122"/>
+                <a:cs typeface="Calibri" pitchFamily="34" charset="-120"/>
+              </a:rPr>
+              <a:t>&lt; 5%</a:t>
+            </a:r>
+            <a:endParaRPr lang="en-US" sz="4600" dirty="0"/>
+          </a:p>
+        </p:txBody>
+      </p:sp>
+      <p:sp>
+        <p:nvSpPr>
+          <p:cNvPr id="6" name="Text 4"/>
+          <p:cNvSpPr/>
+          <p:nvPr/>
+        </p:nvSpPr>
+        <p:spPr>
+          <a:xfrm>
+            <a:off x="822960" y="2468880"/>
+            <a:ext cx="3383280" cy="594360"/>
+          </a:xfrm>
+          <a:prstGeom prst="rect">
+            <a:avLst/>
+          </a:prstGeom>
+          <a:noFill/>
+          <a:ln/>
+        </p:spPr>
+        <p:txBody>
+          <a:bodyPr wrap="square" lIns="0" tIns="0" rIns="0" bIns="0" rtlCol="0" anchor="ctr"/>
+          <a:lstStyle/>
+          <a:p>
+            <a:pPr indent="0" marL="0">
+              <a:lnSpc>
+                <a:spcPts val="1500"/>
+              </a:lnSpc>
+              <a:buNone/>
+            </a:pPr>
+            <a:r>
+              <a:rPr lang="en-US" sz="1200" dirty="0">
+                <a:solidFill>
+                  <a:srgbClr val="475569"/>
+                </a:solidFill>
+                <a:latin typeface="Calibri" pitchFamily="34" charset="0"/>
+                <a:ea typeface="Calibri" pitchFamily="34" charset="-122"/>
+                <a:cs typeface="Calibri" pitchFamily="34" charset="-120"/>
+              </a:rPr>
+              <a:t>dos problemas mapeados se resolvem com ajustes pontuais na planilha atual</a:t>
+            </a:r>
+            <a:endParaRPr lang="en-US" sz="1200" dirty="0"/>
+          </a:p>
+        </p:txBody>
+      </p:sp>
+      <p:sp>
+        <p:nvSpPr>
+          <p:cNvPr id="7" name="Text 5"/>
+          <p:cNvSpPr/>
+          <p:nvPr/>
+        </p:nvSpPr>
+        <p:spPr>
+          <a:xfrm>
+            <a:off x="4846320" y="1554480"/>
+            <a:ext cx="6766560" cy="365760"/>
+          </a:xfrm>
+          <a:prstGeom prst="rect">
+            <a:avLst/>
+          </a:prstGeom>
+          <a:noFill/>
+          <a:ln/>
+        </p:spPr>
+        <p:txBody>
+          <a:bodyPr wrap="square" lIns="0" tIns="0" rIns="0" bIns="0" rtlCol="0" anchor="ctr"/>
+          <a:lstStyle/>
+          <a:p>
+            <a:pPr indent="0" marL="0">
+              <a:buNone/>
+            </a:pPr>
+            <a:r>
+              <a:rPr lang="en-US" sz="1500" b="1" dirty="0">
+                <a:solidFill>
+                  <a:srgbClr val="0F172A"/>
+                </a:solidFill>
+                <a:latin typeface="Calibri" pitchFamily="34" charset="0"/>
+                <a:ea typeface="Calibri" pitchFamily="34" charset="-122"/>
+                <a:cs typeface="Calibri" pitchFamily="34" charset="-120"/>
+              </a:rPr>
+              <a:t>Por que um remendo não paga a conta</a:t>
+            </a:r>
+            <a:endParaRPr lang="en-US" sz="1500" dirty="0"/>
+          </a:p>
+        </p:txBody>
+      </p:sp>
+      <p:sp>
+        <p:nvSpPr>
+          <p:cNvPr id="8" name="Text 6"/>
+          <p:cNvSpPr/>
+          <p:nvPr/>
+        </p:nvSpPr>
+        <p:spPr>
+          <a:xfrm>
+            <a:off x="4846320" y="1920240"/>
+            <a:ext cx="6766560" cy="1188720"/>
+          </a:xfrm>
+          <a:prstGeom prst="rect">
+            <a:avLst/>
+          </a:prstGeom>
+          <a:noFill/>
+          <a:ln/>
+        </p:spPr>
+        <p:txBody>
+          <a:bodyPr wrap="square" lIns="0" tIns="0" rIns="0" bIns="0" rtlCol="0" anchor="ctr"/>
+          <a:lstStyle/>
+          <a:p>
+            <a:pPr indent="0" marL="0">
+              <a:lnSpc>
+                <a:spcPts val="1700"/>
+              </a:lnSpc>
+              <a:buNone/>
+            </a:pPr>
+            <a:r>
+              <a:rPr lang="en-US" sz="1250" dirty="0">
+                <a:solidFill>
+                  <a:srgbClr val="475569"/>
+                </a:solidFill>
+                <a:latin typeface="Calibri" pitchFamily="34" charset="0"/>
+                <a:ea typeface="Calibri" pitchFamily="34" charset="-122"/>
+                <a:cs typeface="Calibri" pitchFamily="34" charset="-120"/>
+              </a:rPr>
+              <a:t>Corrigir performance ou duplicação de regra direto na planilha dá um ganho que desaparece assim que a base cresce de novo — porque o problema está em como o sistema foi construído (Excel funcionando como banco de dados, sem versionamento, sem teste automático), não em um trecho isolado de código.</a:t>
+            </a:r>
+            <a:endParaRPr lang="en-US" sz="1250" dirty="0"/>
+          </a:p>
+        </p:txBody>
+      </p:sp>
+      <p:sp>
+        <p:nvSpPr>
+          <p:cNvPr id="9" name="Shape 7"/>
+          <p:cNvSpPr/>
+          <p:nvPr/>
+        </p:nvSpPr>
+        <p:spPr>
+          <a:xfrm>
+            <a:off x="548640" y="3429000"/>
+            <a:ext cx="5364328" cy="2331720"/>
+          </a:xfrm>
+          <a:prstGeom prst="roundRect">
+            <a:avLst>
+              <a:gd name="adj" fmla="val 3137"/>
+            </a:avLst>
+          </a:prstGeom>
+          <a:solidFill>
+            <a:srgbClr val="FFF7ED"/>
+          </a:solidFill>
+          <a:ln/>
+        </p:spPr>
+      </p:sp>
+      <p:sp>
+        <p:nvSpPr>
+          <p:cNvPr id="10" name="Text 8"/>
+          <p:cNvSpPr/>
+          <p:nvPr/>
+        </p:nvSpPr>
+        <p:spPr>
+          <a:xfrm>
+            <a:off x="822960" y="3611880"/>
+            <a:ext cx="4815688" cy="365760"/>
+          </a:xfrm>
+          <a:prstGeom prst="rect">
+            <a:avLst/>
+          </a:prstGeom>
+          <a:noFill/>
+          <a:ln/>
+        </p:spPr>
+        <p:txBody>
+          <a:bodyPr wrap="square" lIns="0" tIns="0" rIns="0" bIns="0" rtlCol="0" anchor="ctr"/>
+          <a:lstStyle/>
+          <a:p>
+            <a:pPr indent="0" marL="0">
+              <a:buNone/>
+            </a:pPr>
+            <a:r>
+              <a:rPr lang="en-US" sz="1350" b="1" dirty="0">
+                <a:solidFill>
+                  <a:srgbClr val="9A3412"/>
+                </a:solidFill>
+                <a:latin typeface="Calibri" pitchFamily="34" charset="0"/>
+                <a:ea typeface="Calibri" pitchFamily="34" charset="-122"/>
+                <a:cs typeface="Calibri" pitchFamily="34" charset="-120"/>
+              </a:rPr>
+              <a:t>Consertando pontos isolados</a:t>
+            </a:r>
+            <a:endParaRPr lang="en-US" sz="1350" dirty="0"/>
+          </a:p>
+        </p:txBody>
+      </p:sp>
+      <p:sp>
+        <p:nvSpPr>
+          <p:cNvPr id="11" name="Text 9"/>
+          <p:cNvSpPr/>
+          <p:nvPr/>
+        </p:nvSpPr>
+        <p:spPr>
+          <a:xfrm>
+            <a:off x="822960" y="4023360"/>
+            <a:ext cx="4815688" cy="1508760"/>
+          </a:xfrm>
+          <a:prstGeom prst="rect">
+            <a:avLst/>
+          </a:prstGeom>
+          <a:noFill/>
+          <a:ln/>
+        </p:spPr>
+        <p:txBody>
+          <a:bodyPr wrap="square" lIns="0" tIns="0" rIns="0" bIns="0" rtlCol="0" anchor="ctr"/>
+          <a:lstStyle/>
+          <a:p>
+            <a:pPr indent="0" marL="0">
+              <a:lnSpc>
+                <a:spcPts val="1700"/>
+              </a:lnSpc>
+              <a:buNone/>
+            </a:pPr>
+            <a:r>
+              <a:rPr lang="en-US" sz="1250" dirty="0">
+                <a:solidFill>
+                  <a:srgbClr val="7C2D12"/>
+                </a:solidFill>
+                <a:latin typeface="Calibri" pitchFamily="34" charset="0"/>
+                <a:ea typeface="Calibri" pitchFamily="34" charset="-122"/>
+                <a:cs typeface="Calibri" pitchFamily="34" charset="-120"/>
+              </a:rPr>
+              <a:t>Resolve o sintoma mais visível do momento — até a base crescer de novo ou surgir o próximo caso não previsto. Nenhuma das causas estruturais desaparece.</a:t>
+            </a:r>
+            <a:endParaRPr lang="en-US" sz="1250" dirty="0"/>
+          </a:p>
+        </p:txBody>
+      </p:sp>
+      <p:sp>
+        <p:nvSpPr>
+          <p:cNvPr id="12" name="Shape 10"/>
+          <p:cNvSpPr/>
+          <p:nvPr/>
+        </p:nvSpPr>
+        <p:spPr>
+          <a:xfrm>
+            <a:off x="6278728" y="3429000"/>
+            <a:ext cx="5364328" cy="2331720"/>
+          </a:xfrm>
+          <a:prstGeom prst="roundRect">
+            <a:avLst>
+              <a:gd name="adj" fmla="val 3137"/>
+            </a:avLst>
+          </a:prstGeom>
+          <a:solidFill>
+            <a:srgbClr val="ECFDF5"/>
+          </a:solidFill>
+          <a:ln/>
+        </p:spPr>
+      </p:sp>
+      <p:sp>
+        <p:nvSpPr>
+          <p:cNvPr id="13" name="Text 11"/>
+          <p:cNvSpPr/>
+          <p:nvPr/>
+        </p:nvSpPr>
+        <p:spPr>
+          <a:xfrm>
+            <a:off x="6553048" y="3611880"/>
+            <a:ext cx="4815688" cy="365760"/>
+          </a:xfrm>
+          <a:prstGeom prst="rect">
+            <a:avLst/>
+          </a:prstGeom>
+          <a:noFill/>
+          <a:ln/>
+        </p:spPr>
+        <p:txBody>
+          <a:bodyPr wrap="square" lIns="0" tIns="0" rIns="0" bIns="0" rtlCol="0" anchor="ctr"/>
+          <a:lstStyle/>
+          <a:p>
+            <a:pPr indent="0" marL="0">
+              <a:buNone/>
+            </a:pPr>
+            <a:r>
+              <a:rPr lang="en-US" sz="1350" b="1" dirty="0">
+                <a:solidFill>
+                  <a:srgbClr val="047857"/>
+                </a:solidFill>
+                <a:latin typeface="Calibri" pitchFamily="34" charset="0"/>
+                <a:ea typeface="Calibri" pitchFamily="34" charset="-122"/>
+                <a:cs typeface="Calibri" pitchFamily="34" charset="-120"/>
+              </a:rPr>
+              <a:t>Reescrevendo em Python</a:t>
+            </a:r>
+            <a:endParaRPr lang="en-US" sz="1350" dirty="0"/>
+          </a:p>
+        </p:txBody>
+      </p:sp>
+      <p:sp>
+        <p:nvSpPr>
+          <p:cNvPr id="14" name="Text 12"/>
+          <p:cNvSpPr/>
+          <p:nvPr/>
+        </p:nvSpPr>
+        <p:spPr>
+          <a:xfrm>
+            <a:off x="6553048" y="4023360"/>
+            <a:ext cx="4815688" cy="1508760"/>
+          </a:xfrm>
+          <a:prstGeom prst="rect">
+            <a:avLst/>
+          </a:prstGeom>
+          <a:noFill/>
+          <a:ln/>
+        </p:spPr>
+        <p:txBody>
+          <a:bodyPr wrap="square" lIns="0" tIns="0" rIns="0" bIns="0" rtlCol="0" anchor="ctr"/>
+          <a:lstStyle/>
+          <a:p>
+            <a:pPr indent="0" marL="0">
+              <a:lnSpc>
+                <a:spcPts val="1700"/>
+              </a:lnSpc>
+              <a:buNone/>
+            </a:pPr>
+            <a:r>
+              <a:rPr lang="en-US" sz="1250" dirty="0">
+                <a:solidFill>
+                  <a:srgbClr val="065F46"/>
+                </a:solidFill>
+                <a:latin typeface="Calibri" pitchFamily="34" charset="0"/>
+                <a:ea typeface="Calibri" pitchFamily="34" charset="-122"/>
+                <a:cs typeface="Calibri" pitchFamily="34" charset="-120"/>
+              </a:rPr>
+              <a:t>Resolve a causa: um único cálculo testável por regra, dado consistente independente de quem gerou, e performance que não se degrada com o tempo.</a:t>
+            </a:r>
+            <a:endParaRPr lang="en-US" sz="1250" dirty="0"/>
+          </a:p>
+        </p:txBody>
+      </p:sp>
+      <p:sp>
+        <p:nvSpPr>
+          <p:cNvPr id="15" name="Text 13"/>
           <p:cNvSpPr/>
           <p:nvPr/>
         </p:nvSpPr>
@@ -10184,7 +9217,7 @@
       </p:sp>
       <p:sp>
         <p:nvSpPr>
-          <p:cNvPr id="6" name="Text 3"/>
+          <p:cNvPr id="16" name="Text 14"/>
           <p:cNvSpPr/>
           <p:nvPr/>
         </p:nvSpPr>

</xml_diff>

<commit_message>
Adiciona mockups reais do novo Quick Data à apresentação
9 das 10 telas do protótipo (claude.ai/design) inseridas nos slides
de preview; falta apenas a tela de Configurações.

Co-Authored-By: Claude Sonnet 5 <noreply@anthropic.com>
</commit_message>
<xml_diff>
--- a/docs/apresentacao/Quick_Data_Apresentacao.pptx
+++ b/docs/apresentacao/Quick_Data_Apresentacao.pptx
@@ -2793,48 +2793,32 @@
           </a:ln>
         </p:spPr>
       </p:sp>
-      <p:sp>
-        <p:nvSpPr>
-          <p:cNvPr id="5" name="Text 3"/>
-          <p:cNvSpPr/>
-          <p:nvPr/>
-        </p:nvSpPr>
-        <p:spPr>
-          <a:xfrm>
-            <a:off x="548640" y="1417320"/>
-            <a:ext cx="11094415" cy="4709160"/>
-          </a:xfrm>
-          <a:prstGeom prst="rect">
-            <a:avLst/>
-          </a:prstGeom>
-          <a:noFill/>
-          <a:ln/>
-        </p:spPr>
-        <p:txBody>
-          <a:bodyPr wrap="square" lIns="0" tIns="0" rIns="0" bIns="0" rtlCol="0" anchor="ctr"/>
-          <a:lstStyle/>
-          <a:p>
-            <a:pPr algn="ctr" indent="0" marL="0">
-              <a:buNone/>
-            </a:pPr>
-            <a:r>
-              <a:rPr lang="en-US" sz="1600" dirty="0">
-                <a:solidFill>
-                  <a:srgbClr val="94A3B8"/>
-                </a:solidFill>
-                <a:latin typeface="Calibri" pitchFamily="34" charset="0"/>
-                <a:ea typeface="Calibri" pitchFamily="34" charset="-122"/>
-                <a:cs typeface="Calibri" pitchFamily="34" charset="-120"/>
-              </a:rPr>
-              <a:t>[ IMAGEM PENDENTE: 04_ajustes_manuais.png ]</a:t>
-            </a:r>
-            <a:endParaRPr lang="en-US" sz="1600" dirty="0"/>
-          </a:p>
-        </p:txBody>
-      </p:sp>
-      <p:sp>
-        <p:nvSpPr>
-          <p:cNvPr id="6" name="Text 4"/>
+      <p:pic>
+        <p:nvPicPr>
+          <p:cNvPr id="5" name="Image 0" descr="C:\Users\guilm\PycharmProjects\QuickData\docs\mockups\04_ajustes_manuais.png">    </p:cNvPr>
+          <p:cNvPicPr>
+            <a:picLocks noChangeAspect="1"/>
+          </p:cNvPicPr>
+          <p:nvPr/>
+        </p:nvPicPr>
+        <p:blipFill>
+          <a:blip r:embed="rId1"/>
+          <a:srcRect l="0" r="0" t="0" b="0"/>
+          <a:stretch/>
+        </p:blipFill>
+        <p:spPr>
+          <a:xfrm>
+            <a:off x="685800" y="1554480"/>
+            <a:ext cx="10820095" cy="4434840"/>
+          </a:xfrm>
+          <a:prstGeom prst="rect">
+            <a:avLst/>
+          </a:prstGeom>
+        </p:spPr>
+      </p:pic>
+      <p:sp>
+        <p:nvSpPr>
+          <p:cNvPr id="6" name="Text 3"/>
           <p:cNvSpPr/>
           <p:nvPr/>
         </p:nvSpPr>
@@ -2873,7 +2857,7 @@
       </p:sp>
       <p:sp>
         <p:nvSpPr>
-          <p:cNvPr id="7" name="Text 5"/>
+          <p:cNvPr id="7" name="Text 4"/>
           <p:cNvSpPr/>
           <p:nvPr/>
         </p:nvSpPr>
@@ -2912,7 +2896,7 @@
       </p:sp>
       <p:sp>
         <p:nvSpPr>
-          <p:cNvPr id="8" name="Text 6"/>
+          <p:cNvPr id="8" name="Text 5"/>
           <p:cNvSpPr/>
           <p:nvPr/>
         </p:nvSpPr>
@@ -3086,48 +3070,32 @@
           </a:ln>
         </p:spPr>
       </p:sp>
-      <p:sp>
-        <p:nvSpPr>
-          <p:cNvPr id="5" name="Text 3"/>
-          <p:cNvSpPr/>
-          <p:nvPr/>
-        </p:nvSpPr>
-        <p:spPr>
-          <a:xfrm>
-            <a:off x="548640" y="1417320"/>
-            <a:ext cx="11094415" cy="4709160"/>
-          </a:xfrm>
-          <a:prstGeom prst="rect">
-            <a:avLst/>
-          </a:prstGeom>
-          <a:noFill/>
-          <a:ln/>
-        </p:spPr>
-        <p:txBody>
-          <a:bodyPr wrap="square" lIns="0" tIns="0" rIns="0" bIns="0" rtlCol="0" anchor="ctr"/>
-          <a:lstStyle/>
-          <a:p>
-            <a:pPr algn="ctr" indent="0" marL="0">
-              <a:buNone/>
-            </a:pPr>
-            <a:r>
-              <a:rPr lang="en-US" sz="1600" dirty="0">
-                <a:solidFill>
-                  <a:srgbClr val="94A3B8"/>
-                </a:solidFill>
-                <a:latin typeface="Calibri" pitchFamily="34" charset="0"/>
-                <a:ea typeface="Calibri" pitchFamily="34" charset="-122"/>
-                <a:cs typeface="Calibri" pitchFamily="34" charset="-120"/>
-              </a:rPr>
-              <a:t>[ IMAGEM PENDENTE: 05_main_results.png ]</a:t>
-            </a:r>
-            <a:endParaRPr lang="en-US" sz="1600" dirty="0"/>
-          </a:p>
-        </p:txBody>
-      </p:sp>
-      <p:sp>
-        <p:nvSpPr>
-          <p:cNvPr id="6" name="Text 4"/>
+      <p:pic>
+        <p:nvPicPr>
+          <p:cNvPr id="5" name="Image 0" descr="C:\Users\guilm\PycharmProjects\QuickData\docs\mockups\05_main_results.png">    </p:cNvPr>
+          <p:cNvPicPr>
+            <a:picLocks noChangeAspect="1"/>
+          </p:cNvPicPr>
+          <p:nvPr/>
+        </p:nvPicPr>
+        <p:blipFill>
+          <a:blip r:embed="rId1"/>
+          <a:srcRect l="0" r="0" t="0" b="0"/>
+          <a:stretch/>
+        </p:blipFill>
+        <p:spPr>
+          <a:xfrm>
+            <a:off x="685800" y="1554480"/>
+            <a:ext cx="10820095" cy="4434840"/>
+          </a:xfrm>
+          <a:prstGeom prst="rect">
+            <a:avLst/>
+          </a:prstGeom>
+        </p:spPr>
+      </p:pic>
+      <p:sp>
+        <p:nvSpPr>
+          <p:cNvPr id="6" name="Text 3"/>
           <p:cNvSpPr/>
           <p:nvPr/>
         </p:nvSpPr>
@@ -3166,7 +3134,7 @@
       </p:sp>
       <p:sp>
         <p:nvSpPr>
-          <p:cNvPr id="7" name="Text 5"/>
+          <p:cNvPr id="7" name="Text 4"/>
           <p:cNvSpPr/>
           <p:nvPr/>
         </p:nvSpPr>
@@ -3205,7 +3173,7 @@
       </p:sp>
       <p:sp>
         <p:nvSpPr>
-          <p:cNvPr id="8" name="Text 6"/>
+          <p:cNvPr id="8" name="Text 5"/>
           <p:cNvSpPr/>
           <p:nvPr/>
         </p:nvSpPr>
@@ -3379,48 +3347,32 @@
           </a:ln>
         </p:spPr>
       </p:sp>
-      <p:sp>
-        <p:nvSpPr>
-          <p:cNvPr id="5" name="Text 3"/>
-          <p:cNvSpPr/>
-          <p:nvPr/>
-        </p:nvSpPr>
-        <p:spPr>
-          <a:xfrm>
-            <a:off x="548640" y="1463040"/>
-            <a:ext cx="3545738" cy="1783080"/>
-          </a:xfrm>
-          <a:prstGeom prst="rect">
-            <a:avLst/>
-          </a:prstGeom>
-          <a:noFill/>
-          <a:ln/>
-        </p:spPr>
-        <p:txBody>
-          <a:bodyPr wrap="square" lIns="0" tIns="0" rIns="0" bIns="0" rtlCol="0" anchor="ctr"/>
-          <a:lstStyle/>
-          <a:p>
-            <a:pPr algn="ctr" indent="0" marL="0">
-              <a:buNone/>
-            </a:pPr>
-            <a:r>
-              <a:rPr lang="en-US" sz="1100" dirty="0">
-                <a:solidFill>
-                  <a:srgbClr val="94A3B8"/>
-                </a:solidFill>
-                <a:latin typeface="Calibri" pitchFamily="34" charset="0"/>
-                <a:ea typeface="Calibri" pitchFamily="34" charset="-122"/>
-                <a:cs typeface="Calibri" pitchFamily="34" charset="-120"/>
-              </a:rPr>
-              <a:t>[ pendente ]</a:t>
-            </a:r>
-            <a:endParaRPr lang="en-US" sz="1100" dirty="0"/>
-          </a:p>
-        </p:txBody>
-      </p:sp>
-      <p:sp>
-        <p:nvSpPr>
-          <p:cNvPr id="6" name="Text 4"/>
+      <p:pic>
+        <p:nvPicPr>
+          <p:cNvPr id="5" name="Image 0" descr="C:\Users\guilm\PycharmProjects\QuickData\docs\mockups\06_historico_de_extracoes.png">    </p:cNvPr>
+          <p:cNvPicPr>
+            <a:picLocks noChangeAspect="1"/>
+          </p:cNvPicPr>
+          <p:nvPr/>
+        </p:nvPicPr>
+        <p:blipFill>
+          <a:blip r:embed="rId1"/>
+          <a:srcRect l="0" r="0" t="0" b="0"/>
+          <a:stretch/>
+        </p:blipFill>
+        <p:spPr>
+          <a:xfrm>
+            <a:off x="621792" y="1536192"/>
+            <a:ext cx="3399434" cy="1636776"/>
+          </a:xfrm>
+          <a:prstGeom prst="rect">
+            <a:avLst/>
+          </a:prstGeom>
+        </p:spPr>
+      </p:pic>
+      <p:sp>
+        <p:nvSpPr>
+          <p:cNvPr id="6" name="Text 3"/>
           <p:cNvSpPr/>
           <p:nvPr/>
         </p:nvSpPr>
@@ -3459,7 +3411,7 @@
       </p:sp>
       <p:sp>
         <p:nvSpPr>
-          <p:cNvPr id="7" name="Shape 5"/>
+          <p:cNvPr id="7" name="Shape 4"/>
           <p:cNvSpPr/>
           <p:nvPr/>
         </p:nvSpPr>
@@ -3484,48 +3436,32 @@
           </a:ln>
         </p:spPr>
       </p:sp>
-      <p:sp>
-        <p:nvSpPr>
-          <p:cNvPr id="8" name="Text 6"/>
-          <p:cNvSpPr/>
-          <p:nvPr/>
-        </p:nvSpPr>
-        <p:spPr>
-          <a:xfrm>
-            <a:off x="4322978" y="1463040"/>
-            <a:ext cx="3545738" cy="1783080"/>
-          </a:xfrm>
-          <a:prstGeom prst="rect">
-            <a:avLst/>
-          </a:prstGeom>
-          <a:noFill/>
-          <a:ln/>
-        </p:spPr>
-        <p:txBody>
-          <a:bodyPr wrap="square" lIns="0" tIns="0" rIns="0" bIns="0" rtlCol="0" anchor="ctr"/>
-          <a:lstStyle/>
-          <a:p>
-            <a:pPr algn="ctr" indent="0" marL="0">
-              <a:buNone/>
-            </a:pPr>
-            <a:r>
-              <a:rPr lang="en-US" sz="1100" dirty="0">
-                <a:solidFill>
-                  <a:srgbClr val="94A3B8"/>
-                </a:solidFill>
-                <a:latin typeface="Calibri" pitchFamily="34" charset="0"/>
-                <a:ea typeface="Calibri" pitchFamily="34" charset="-122"/>
-                <a:cs typeface="Calibri" pitchFamily="34" charset="-120"/>
-              </a:rPr>
-              <a:t>[ pendente ]</a:t>
-            </a:r>
-            <a:endParaRPr lang="en-US" sz="1100" dirty="0"/>
-          </a:p>
-        </p:txBody>
-      </p:sp>
-      <p:sp>
-        <p:nvSpPr>
-          <p:cNvPr id="9" name="Text 7"/>
+      <p:pic>
+        <p:nvPicPr>
+          <p:cNvPr id="8" name="Image 1" descr="C:\Users\guilm\PycharmProjects\QuickData\docs\mockups\07_log_console.png">    </p:cNvPr>
+          <p:cNvPicPr>
+            <a:picLocks noChangeAspect="1"/>
+          </p:cNvPicPr>
+          <p:nvPr/>
+        </p:nvPicPr>
+        <p:blipFill>
+          <a:blip r:embed="rId2"/>
+          <a:srcRect l="0" r="0" t="0" b="0"/>
+          <a:stretch/>
+        </p:blipFill>
+        <p:spPr>
+          <a:xfrm>
+            <a:off x="4396130" y="1536192"/>
+            <a:ext cx="3399434" cy="1636776"/>
+          </a:xfrm>
+          <a:prstGeom prst="rect">
+            <a:avLst/>
+          </a:prstGeom>
+        </p:spPr>
+      </p:pic>
+      <p:sp>
+        <p:nvSpPr>
+          <p:cNvPr id="9" name="Text 5"/>
           <p:cNvSpPr/>
           <p:nvPr/>
         </p:nvSpPr>
@@ -3564,7 +3500,7 @@
       </p:sp>
       <p:sp>
         <p:nvSpPr>
-          <p:cNvPr id="10" name="Shape 8"/>
+          <p:cNvPr id="10" name="Shape 6"/>
           <p:cNvSpPr/>
           <p:nvPr/>
         </p:nvSpPr>
@@ -3591,7 +3527,7 @@
       </p:sp>
       <p:sp>
         <p:nvSpPr>
-          <p:cNvPr id="11" name="Text 9"/>
+          <p:cNvPr id="11" name="Text 7"/>
           <p:cNvSpPr/>
           <p:nvPr/>
         </p:nvSpPr>
@@ -3630,7 +3566,7 @@
       </p:sp>
       <p:sp>
         <p:nvSpPr>
-          <p:cNvPr id="12" name="Text 10"/>
+          <p:cNvPr id="12" name="Text 8"/>
           <p:cNvSpPr/>
           <p:nvPr/>
         </p:nvSpPr>
@@ -3669,7 +3605,7 @@
       </p:sp>
       <p:sp>
         <p:nvSpPr>
-          <p:cNvPr id="13" name="Shape 11"/>
+          <p:cNvPr id="13" name="Shape 9"/>
           <p:cNvSpPr/>
           <p:nvPr/>
         </p:nvSpPr>
@@ -3694,48 +3630,32 @@
           </a:ln>
         </p:spPr>
       </p:sp>
-      <p:sp>
-        <p:nvSpPr>
-          <p:cNvPr id="14" name="Text 12"/>
-          <p:cNvSpPr/>
-          <p:nvPr/>
-        </p:nvSpPr>
-        <p:spPr>
-          <a:xfrm>
-            <a:off x="548640" y="3749040"/>
-            <a:ext cx="3545738" cy="1783080"/>
-          </a:xfrm>
-          <a:prstGeom prst="rect">
-            <a:avLst/>
-          </a:prstGeom>
-          <a:noFill/>
-          <a:ln/>
-        </p:spPr>
-        <p:txBody>
-          <a:bodyPr wrap="square" lIns="0" tIns="0" rIns="0" bIns="0" rtlCol="0" anchor="ctr"/>
-          <a:lstStyle/>
-          <a:p>
-            <a:pPr algn="ctr" indent="0" marL="0">
-              <a:buNone/>
-            </a:pPr>
-            <a:r>
-              <a:rPr lang="en-US" sz="1100" dirty="0">
-                <a:solidFill>
-                  <a:srgbClr val="94A3B8"/>
-                </a:solidFill>
-                <a:latin typeface="Calibri" pitchFamily="34" charset="0"/>
-                <a:ea typeface="Calibri" pitchFamily="34" charset="-122"/>
-                <a:cs typeface="Calibri" pitchFamily="34" charset="-120"/>
-              </a:rPr>
-              <a:t>[ pendente ]</a:t>
-            </a:r>
-            <a:endParaRPr lang="en-US" sz="1100" dirty="0"/>
-          </a:p>
-        </p:txBody>
-      </p:sp>
-      <p:sp>
-        <p:nvSpPr>
-          <p:cNvPr id="15" name="Text 13"/>
+      <p:pic>
+        <p:nvPicPr>
+          <p:cNvPr id="14" name="Image 2" descr="C:\Users\guilm\PycharmProjects\QuickData\docs\mockups\09_manual.png">    </p:cNvPr>
+          <p:cNvPicPr>
+            <a:picLocks noChangeAspect="1"/>
+          </p:cNvPicPr>
+          <p:nvPr/>
+        </p:nvPicPr>
+        <p:blipFill>
+          <a:blip r:embed="rId3"/>
+          <a:srcRect l="0" r="0" t="0" b="0"/>
+          <a:stretch/>
+        </p:blipFill>
+        <p:spPr>
+          <a:xfrm>
+            <a:off x="621792" y="3822192"/>
+            <a:ext cx="3399434" cy="1636776"/>
+          </a:xfrm>
+          <a:prstGeom prst="rect">
+            <a:avLst/>
+          </a:prstGeom>
+        </p:spPr>
+      </p:pic>
+      <p:sp>
+        <p:nvSpPr>
+          <p:cNvPr id="15" name="Text 10"/>
           <p:cNvSpPr/>
           <p:nvPr/>
         </p:nvSpPr>
@@ -3774,7 +3694,7 @@
       </p:sp>
       <p:sp>
         <p:nvSpPr>
-          <p:cNvPr id="16" name="Shape 14"/>
+          <p:cNvPr id="16" name="Shape 11"/>
           <p:cNvSpPr/>
           <p:nvPr/>
         </p:nvSpPr>
@@ -3799,48 +3719,32 @@
           </a:ln>
         </p:spPr>
       </p:sp>
-      <p:sp>
-        <p:nvSpPr>
-          <p:cNvPr id="17" name="Text 15"/>
-          <p:cNvSpPr/>
-          <p:nvPr/>
-        </p:nvSpPr>
-        <p:spPr>
-          <a:xfrm>
-            <a:off x="4322978" y="3749040"/>
-            <a:ext cx="3545738" cy="1783080"/>
-          </a:xfrm>
-          <a:prstGeom prst="rect">
-            <a:avLst/>
-          </a:prstGeom>
-          <a:noFill/>
-          <a:ln/>
-        </p:spPr>
-        <p:txBody>
-          <a:bodyPr wrap="square" lIns="0" tIns="0" rIns="0" bIns="0" rtlCol="0" anchor="ctr"/>
-          <a:lstStyle/>
-          <a:p>
-            <a:pPr algn="ctr" indent="0" marL="0">
-              <a:buNone/>
-            </a:pPr>
-            <a:r>
-              <a:rPr lang="en-US" sz="1100" dirty="0">
-                <a:solidFill>
-                  <a:srgbClr val="94A3B8"/>
-                </a:solidFill>
-                <a:latin typeface="Calibri" pitchFamily="34" charset="0"/>
-                <a:ea typeface="Calibri" pitchFamily="34" charset="-122"/>
-                <a:cs typeface="Calibri" pitchFamily="34" charset="-120"/>
-              </a:rPr>
-              <a:t>[ pendente ]</a:t>
-            </a:r>
-            <a:endParaRPr lang="en-US" sz="1100" dirty="0"/>
-          </a:p>
-        </p:txBody>
-      </p:sp>
-      <p:sp>
-        <p:nvSpPr>
-          <p:cNvPr id="18" name="Text 16"/>
+      <p:pic>
+        <p:nvPicPr>
+          <p:cNvPr id="17" name="Image 3" descr="C:\Users\guilm\PycharmProjects\QuickData\docs\mockups\10_atualizacoes.png">    </p:cNvPr>
+          <p:cNvPicPr>
+            <a:picLocks noChangeAspect="1"/>
+          </p:cNvPicPr>
+          <p:nvPr/>
+        </p:nvPicPr>
+        <p:blipFill>
+          <a:blip r:embed="rId4"/>
+          <a:srcRect l="0" r="0" t="0" b="0"/>
+          <a:stretch/>
+        </p:blipFill>
+        <p:spPr>
+          <a:xfrm>
+            <a:off x="4396130" y="3822192"/>
+            <a:ext cx="3399434" cy="1636776"/>
+          </a:xfrm>
+          <a:prstGeom prst="rect">
+            <a:avLst/>
+          </a:prstGeom>
+        </p:spPr>
+      </p:pic>
+      <p:sp>
+        <p:nvSpPr>
+          <p:cNvPr id="18" name="Text 12"/>
           <p:cNvSpPr/>
           <p:nvPr/>
         </p:nvSpPr>
@@ -3879,7 +3783,7 @@
       </p:sp>
       <p:sp>
         <p:nvSpPr>
-          <p:cNvPr id="19" name="Shape 17"/>
+          <p:cNvPr id="19" name="Shape 13"/>
           <p:cNvSpPr/>
           <p:nvPr/>
         </p:nvSpPr>
@@ -3904,48 +3808,32 @@
           </a:ln>
         </p:spPr>
       </p:sp>
-      <p:sp>
-        <p:nvSpPr>
-          <p:cNvPr id="20" name="Text 18"/>
-          <p:cNvSpPr/>
-          <p:nvPr/>
-        </p:nvSpPr>
-        <p:spPr>
-          <a:xfrm>
-            <a:off x="8097317" y="3749040"/>
-            <a:ext cx="3545738" cy="1783080"/>
-          </a:xfrm>
-          <a:prstGeom prst="rect">
-            <a:avLst/>
-          </a:prstGeom>
-          <a:noFill/>
-          <a:ln/>
-        </p:spPr>
-        <p:txBody>
-          <a:bodyPr wrap="square" lIns="0" tIns="0" rIns="0" bIns="0" rtlCol="0" anchor="ctr"/>
-          <a:lstStyle/>
-          <a:p>
-            <a:pPr algn="ctr" indent="0" marL="0">
-              <a:buNone/>
-            </a:pPr>
-            <a:r>
-              <a:rPr lang="en-US" sz="1100" dirty="0">
-                <a:solidFill>
-                  <a:srgbClr val="94A3B8"/>
-                </a:solidFill>
-                <a:latin typeface="Calibri" pitchFamily="34" charset="0"/>
-                <a:ea typeface="Calibri" pitchFamily="34" charset="-122"/>
-                <a:cs typeface="Calibri" pitchFamily="34" charset="-120"/>
-              </a:rPr>
-              <a:t>[ pendente ]</a:t>
-            </a:r>
-            <a:endParaRPr lang="en-US" sz="1100" dirty="0"/>
-          </a:p>
-        </p:txBody>
-      </p:sp>
-      <p:sp>
-        <p:nvSpPr>
-          <p:cNvPr id="21" name="Text 19"/>
+      <p:pic>
+        <p:nvPicPr>
+          <p:cNvPr id="20" name="Image 4" descr="C:\Users\guilm\PycharmProjects\QuickData\docs\mockups\11_relatar_bug.png">    </p:cNvPr>
+          <p:cNvPicPr>
+            <a:picLocks noChangeAspect="1"/>
+          </p:cNvPicPr>
+          <p:nvPr/>
+        </p:nvPicPr>
+        <p:blipFill>
+          <a:blip r:embed="rId5"/>
+          <a:srcRect l="0" r="0" t="0" b="0"/>
+          <a:stretch/>
+        </p:blipFill>
+        <p:spPr>
+          <a:xfrm>
+            <a:off x="8170469" y="3822192"/>
+            <a:ext cx="3399434" cy="1636776"/>
+          </a:xfrm>
+          <a:prstGeom prst="rect">
+            <a:avLst/>
+          </a:prstGeom>
+        </p:spPr>
+      </p:pic>
+      <p:sp>
+        <p:nvSpPr>
+          <p:cNvPr id="21" name="Text 14"/>
           <p:cNvSpPr/>
           <p:nvPr/>
         </p:nvSpPr>
@@ -3984,7 +3872,7 @@
       </p:sp>
       <p:sp>
         <p:nvSpPr>
-          <p:cNvPr id="22" name="Text 20"/>
+          <p:cNvPr id="22" name="Text 15"/>
           <p:cNvSpPr/>
           <p:nvPr/>
         </p:nvSpPr>
@@ -4023,7 +3911,7 @@
       </p:sp>
       <p:sp>
         <p:nvSpPr>
-          <p:cNvPr id="23" name="Text 21"/>
+          <p:cNvPr id="23" name="Text 16"/>
           <p:cNvSpPr/>
           <p:nvPr/>
         </p:nvSpPr>
@@ -9983,48 +9871,32 @@
           </a:ln>
         </p:spPr>
       </p:sp>
-      <p:sp>
-        <p:nvSpPr>
-          <p:cNvPr id="5" name="Text 3"/>
-          <p:cNvSpPr/>
-          <p:nvPr/>
-        </p:nvSpPr>
-        <p:spPr>
-          <a:xfrm>
-            <a:off x="548640" y="1417320"/>
-            <a:ext cx="11094415" cy="4709160"/>
-          </a:xfrm>
-          <a:prstGeom prst="rect">
-            <a:avLst/>
-          </a:prstGeom>
-          <a:noFill/>
-          <a:ln/>
-        </p:spPr>
-        <p:txBody>
-          <a:bodyPr wrap="square" lIns="0" tIns="0" rIns="0" bIns="0" rtlCol="0" anchor="ctr"/>
-          <a:lstStyle/>
-          <a:p>
-            <a:pPr algn="ctr" indent="0" marL="0">
-              <a:buNone/>
-            </a:pPr>
-            <a:r>
-              <a:rPr lang="en-US" sz="1600" dirty="0">
-                <a:solidFill>
-                  <a:srgbClr val="94A3B8"/>
-                </a:solidFill>
-                <a:latin typeface="Calibri" pitchFamily="34" charset="0"/>
-                <a:ea typeface="Calibri" pitchFamily="34" charset="-122"/>
-                <a:cs typeface="Calibri" pitchFamily="34" charset="-120"/>
-              </a:rPr>
-              <a:t>[ IMAGEM PENDENTE: 02_painel_principal.png ]</a:t>
-            </a:r>
-            <a:endParaRPr lang="en-US" sz="1600" dirty="0"/>
-          </a:p>
-        </p:txBody>
-      </p:sp>
-      <p:sp>
-        <p:nvSpPr>
-          <p:cNvPr id="6" name="Text 4"/>
+      <p:pic>
+        <p:nvPicPr>
+          <p:cNvPr id="5" name="Image 0" descr="C:\Users\guilm\PycharmProjects\QuickData\docs\mockups\02_painel_principal.png">    </p:cNvPr>
+          <p:cNvPicPr>
+            <a:picLocks noChangeAspect="1"/>
+          </p:cNvPicPr>
+          <p:nvPr/>
+        </p:nvPicPr>
+        <p:blipFill>
+          <a:blip r:embed="rId1"/>
+          <a:srcRect l="0" r="0" t="0" b="0"/>
+          <a:stretch/>
+        </p:blipFill>
+        <p:spPr>
+          <a:xfrm>
+            <a:off x="685800" y="1554480"/>
+            <a:ext cx="10820095" cy="4434840"/>
+          </a:xfrm>
+          <a:prstGeom prst="rect">
+            <a:avLst/>
+          </a:prstGeom>
+        </p:spPr>
+      </p:pic>
+      <p:sp>
+        <p:nvSpPr>
+          <p:cNvPr id="6" name="Text 3"/>
           <p:cNvSpPr/>
           <p:nvPr/>
         </p:nvSpPr>
@@ -10063,7 +9935,7 @@
       </p:sp>
       <p:sp>
         <p:nvSpPr>
-          <p:cNvPr id="7" name="Text 5"/>
+          <p:cNvPr id="7" name="Text 4"/>
           <p:cNvSpPr/>
           <p:nvPr/>
         </p:nvSpPr>
@@ -10102,7 +9974,7 @@
       </p:sp>
       <p:sp>
         <p:nvSpPr>
-          <p:cNvPr id="8" name="Text 6"/>
+          <p:cNvPr id="8" name="Text 5"/>
           <p:cNvSpPr/>
           <p:nvPr/>
         </p:nvSpPr>
@@ -10276,48 +10148,32 @@
           </a:ln>
         </p:spPr>
       </p:sp>
-      <p:sp>
-        <p:nvSpPr>
-          <p:cNvPr id="5" name="Text 3"/>
-          <p:cNvSpPr/>
-          <p:nvPr/>
-        </p:nvSpPr>
-        <p:spPr>
-          <a:xfrm>
-            <a:off x="548640" y="1417320"/>
-            <a:ext cx="11094415" cy="4709160"/>
-          </a:xfrm>
-          <a:prstGeom prst="rect">
-            <a:avLst/>
-          </a:prstGeom>
-          <a:noFill/>
-          <a:ln/>
-        </p:spPr>
-        <p:txBody>
-          <a:bodyPr wrap="square" lIns="0" tIns="0" rIns="0" bIns="0" rtlCol="0" anchor="ctr"/>
-          <a:lstStyle/>
-          <a:p>
-            <a:pPr algn="ctr" indent="0" marL="0">
-              <a:buNone/>
-            </a:pPr>
-            <a:r>
-              <a:rPr lang="en-US" sz="1600" dirty="0">
-                <a:solidFill>
-                  <a:srgbClr val="94A3B8"/>
-                </a:solidFill>
-                <a:latin typeface="Calibri" pitchFamily="34" charset="0"/>
-                <a:ea typeface="Calibri" pitchFamily="34" charset="-122"/>
-                <a:cs typeface="Calibri" pitchFamily="34" charset="-120"/>
-              </a:rPr>
-              <a:t>[ IMAGEM PENDENTE: 03_extracao_de_dados.png ]</a:t>
-            </a:r>
-            <a:endParaRPr lang="en-US" sz="1600" dirty="0"/>
-          </a:p>
-        </p:txBody>
-      </p:sp>
-      <p:sp>
-        <p:nvSpPr>
-          <p:cNvPr id="6" name="Text 4"/>
+      <p:pic>
+        <p:nvPicPr>
+          <p:cNvPr id="5" name="Image 0" descr="C:\Users\guilm\PycharmProjects\QuickData\docs\mockups\03_extracao_de_dados.png">    </p:cNvPr>
+          <p:cNvPicPr>
+            <a:picLocks noChangeAspect="1"/>
+          </p:cNvPicPr>
+          <p:nvPr/>
+        </p:nvPicPr>
+        <p:blipFill>
+          <a:blip r:embed="rId1"/>
+          <a:srcRect l="0" r="0" t="0" b="0"/>
+          <a:stretch/>
+        </p:blipFill>
+        <p:spPr>
+          <a:xfrm>
+            <a:off x="685800" y="1554480"/>
+            <a:ext cx="10820095" cy="4434840"/>
+          </a:xfrm>
+          <a:prstGeom prst="rect">
+            <a:avLst/>
+          </a:prstGeom>
+        </p:spPr>
+      </p:pic>
+      <p:sp>
+        <p:nvSpPr>
+          <p:cNvPr id="6" name="Text 3"/>
           <p:cNvSpPr/>
           <p:nvPr/>
         </p:nvSpPr>
@@ -10356,7 +10212,7 @@
       </p:sp>
       <p:sp>
         <p:nvSpPr>
-          <p:cNvPr id="7" name="Text 5"/>
+          <p:cNvPr id="7" name="Text 4"/>
           <p:cNvSpPr/>
           <p:nvPr/>
         </p:nvSpPr>
@@ -10395,7 +10251,7 @@
       </p:sp>
       <p:sp>
         <p:nvSpPr>
-          <p:cNvPr id="8" name="Text 6"/>
+          <p:cNvPr id="8" name="Text 5"/>
           <p:cNvSpPr/>
           <p:nvPr/>
         </p:nvSpPr>

</xml_diff>